<commit_message>
Regenerate PowerPoint for song #2 in fubc-ua
</commit_message>
<xml_diff>
--- a/fubc-ua/2-Чим справді цінний Богу я (My Worth Is Not In What I Own).pptx
+++ b/fubc-ua/2-Чим справді цінний Богу я (My Worth Is Not In What I Own).pptx
@@ -12,9 +12,10 @@
     <p:sldId id="260" r:id="rId6"/>
     <p:sldId id="261" r:id="rId7"/>
     <p:sldId id="262" r:id="rId8"/>
+    <p:sldId id="263" r:id="rId9"/>
   </p:sldIdLst>
   <p:notesMasterIdLst>
-    <p:notesMasterId r:id="rId9"/>
+    <p:notesMasterId r:id="rId10"/>
   </p:notesMasterIdLst>
   <p:sldSz cx="12192000" cy="6858000"/>
   <p:notesSz cx="6858000" cy="12192000"/>
@@ -1060,6 +1061,94 @@
             <a:fld id="{F7021451-1387-4CA6-816F-3879F97B5CBC}" type="slidenum">
               <a:rPr lang="en-US"/>
               <a:t>7</a:t>
+            </a:fld>
+            <a:endParaRPr lang="en-US"/>
+          </a:p>
+        </p:txBody>
+      </p:sp>
+    </p:spTree>
+    <p:extLst>
+      <p:ext uri="{BB962C8B-B14F-4D97-AF65-F5344CB8AC3E}">
+        <p14:creationId xmlns:p14="http://schemas.microsoft.com/office/powerpoint/2010/main" val="1024086991"/>
+      </p:ext>
+    </p:extLst>
+  </p:cSld>
+  <p:clrMapOvr>
+    <a:masterClrMapping/>
+  </p:clrMapOvr>
+</p:notes>
+</file>
+
+<file path=ppt/notesSlides/notesSlide8.xml><?xml version="1.0" encoding="utf-8"?>
+<p:notes xmlns:a="http://schemas.openxmlformats.org/drawingml/2006/main" xmlns:r="http://schemas.openxmlformats.org/officeDocument/2006/relationships" xmlns:p="http://schemas.openxmlformats.org/presentationml/2006/main">
+  <p:cSld>
+    <p:spTree>
+      <p:nvGrpSpPr>
+        <p:cNvPr id="1" name=""/>
+        <p:cNvGrpSpPr/>
+        <p:nvPr/>
+      </p:nvGrpSpPr>
+      <p:grpSpPr>
+        <a:xfrm>
+          <a:off x="0" y="0"/>
+          <a:ext cx="0" cy="0"/>
+          <a:chOff x="0" y="0"/>
+          <a:chExt cx="0" cy="0"/>
+        </a:xfrm>
+      </p:grpSpPr>
+      <p:sp>
+        <p:nvSpPr>
+          <p:cNvPr id="2" name="Slide Image Placeholder 1"/>
+          <p:cNvSpPr>
+            <a:spLocks noGrp="1" noRot="1" noChangeAspect="1"/>
+          </p:cNvSpPr>
+          <p:nvPr>
+            <p:ph type="sldImg"/>
+          </p:nvPr>
+        </p:nvSpPr>
+        <p:spPr/>
+      </p:sp>
+      <p:sp>
+        <p:nvSpPr>
+          <p:cNvPr id="3" name="Notes Placeholder 2"/>
+          <p:cNvSpPr>
+            <a:spLocks noGrp="1"/>
+          </p:cNvSpPr>
+          <p:nvPr>
+            <p:ph type="body" idx="1"/>
+          </p:nvPr>
+        </p:nvSpPr>
+        <p:spPr/>
+        <p:txBody>
+          <a:bodyPr/>
+          <a:lstStyle/>
+          <a:p>
+            <a:r>
+              <a:rPr lang="en-US" dirty="0"/>
+              <a:t/>
+            </a:r>
+            <a:endParaRPr lang="en-US" dirty="0"/>
+          </a:p>
+        </p:txBody>
+      </p:sp>
+      <p:sp>
+        <p:nvSpPr>
+          <p:cNvPr id="4" name="Slide Number Placeholder 3"/>
+          <p:cNvSpPr>
+            <a:spLocks noGrp="1"/>
+          </p:cNvSpPr>
+          <p:nvPr>
+            <p:ph type="sldNum" sz="quarter" idx="10"/>
+          </p:nvPr>
+        </p:nvSpPr>
+        <p:spPr/>
+        <p:txBody>
+          <a:bodyPr/>
+          <a:lstStyle/>
+          <a:p>
+            <a:fld id="{F7021451-1387-4CA6-816F-3879F97B5CBC}" type="slidenum">
+              <a:rPr lang="en-US"/>
+              <a:t>8</a:t>
             </a:fld>
             <a:endParaRPr lang="en-US"/>
           </a:p>
@@ -1434,85 +1523,17 @@
               <a:buNone/>
             </a:pPr>
             <a:r>
-              <a:rPr lang="en-US" sz="4000" b="1" dirty="0">
-                <a:solidFill>
-                  <a:srgbClr val="FFFFFF"/>
-                </a:solidFill>
-                <a:latin typeface="Arial" pitchFamily="34" charset="0"/>
-                <a:ea typeface="Arial" pitchFamily="34" charset="-122"/>
-                <a:cs typeface="Arial" pitchFamily="34" charset="-120"/>
-              </a:rPr>
-              <a:t>Чим справді цінний Богу я?</a:t>
-            </a:r>
-            <a:endParaRPr lang="en-US" sz="4000" dirty="0"/>
-          </a:p>
-          <a:p>
-            <a:pPr algn="ctr" indent="0" marL="0">
-              <a:buNone/>
-            </a:pPr>
-            <a:r>
-              <a:rPr lang="en-US" sz="4000" b="1" dirty="0">
-                <a:solidFill>
-                  <a:srgbClr val="FFFFFF"/>
-                </a:solidFill>
-                <a:latin typeface="Arial" pitchFamily="34" charset="0"/>
-                <a:ea typeface="Arial" pitchFamily="34" charset="-122"/>
-                <a:cs typeface="Arial" pitchFamily="34" charset="-120"/>
-              </a:rPr>
-              <a:t>Ніщо – багатство чи краса.</a:t>
-            </a:r>
-            <a:endParaRPr lang="en-US" sz="4000" dirty="0"/>
-          </a:p>
-          <a:p>
-            <a:pPr algn="ctr" indent="0" marL="0">
-              <a:buNone/>
-            </a:pPr>
-            <a:r>
-              <a:rPr lang="en-US" sz="4000" b="1" dirty="0">
-                <a:solidFill>
-                  <a:srgbClr val="FFFFFF"/>
-                </a:solidFill>
-                <a:latin typeface="Arial" pitchFamily="34" charset="0"/>
-                <a:ea typeface="Arial" pitchFamily="34" charset="-122"/>
-                <a:cs typeface="Arial" pitchFamily="34" charset="-120"/>
-              </a:rPr>
-              <a:t>Христос пролив любов святу на хресті!</a:t>
-            </a:r>
-            <a:endParaRPr lang="en-US" sz="4000" dirty="0"/>
-          </a:p>
-          <a:p>
-            <a:pPr algn="ctr" indent="0" marL="0">
-              <a:buNone/>
-            </a:pPr>
-            <a:r>
-              <a:rPr lang="en-US" sz="4000" b="1" dirty="0">
-                <a:solidFill>
-                  <a:srgbClr val="FFFFFF"/>
-                </a:solidFill>
-                <a:latin typeface="Arial" pitchFamily="34" charset="0"/>
-                <a:ea typeface="Arial" pitchFamily="34" charset="-122"/>
-                <a:cs typeface="Arial" pitchFamily="34" charset="-120"/>
-              </a:rPr>
-              <a:t>Не маю слави у собі, y перемозі чи в біді</a:t>
-            </a:r>
-            <a:endParaRPr lang="en-US" sz="4000" dirty="0"/>
-          </a:p>
-          <a:p>
-            <a:pPr algn="ctr" indent="0" marL="0">
-              <a:buNone/>
-            </a:pPr>
-            <a:r>
-              <a:rPr lang="en-US" sz="4000" b="1" dirty="0">
-                <a:solidFill>
-                  <a:srgbClr val="FFFFFF"/>
-                </a:solidFill>
-                <a:latin typeface="Arial" pitchFamily="34" charset="0"/>
-                <a:ea typeface="Arial" pitchFamily="34" charset="-122"/>
-                <a:cs typeface="Arial" pitchFamily="34" charset="-120"/>
-              </a:rPr>
-              <a:t>Ісус за мене заплатив на хресті!</a:t>
-            </a:r>
-            <a:endParaRPr lang="en-US" sz="4000" dirty="0"/>
+              <a:rPr lang="en-US" sz="4800" b="1" dirty="0">
+                <a:solidFill>
+                  <a:srgbClr val="FFFFFF"/>
+                </a:solidFill>
+                <a:latin typeface="Arial" pitchFamily="34" charset="0"/>
+                <a:ea typeface="Arial" pitchFamily="34" charset="-122"/>
+                <a:cs typeface="Arial" pitchFamily="34" charset="-120"/>
+              </a:rPr>
+              <a:t>Чим справді цінний Богу я? (My Worth Is Not In What I Own)</a:t>
+            </a:r>
+            <a:endParaRPr lang="en-US" sz="4800" dirty="0"/>
           </a:p>
         </p:txBody>
       </p:sp>
@@ -1573,68 +1594,85 @@
               <a:buNone/>
             </a:pPr>
             <a:r>
-              <a:rPr lang="en-US" sz="4000" b="1" i="1" dirty="0">
-                <a:solidFill>
-                  <a:srgbClr val="FFFFFF"/>
-                </a:solidFill>
-                <a:latin typeface="Arial" pitchFamily="34" charset="0"/>
-                <a:ea typeface="Arial" pitchFamily="34" charset="-122"/>
-                <a:cs typeface="Arial" pitchFamily="34" charset="-120"/>
-              </a:rPr>
-              <a:t>Я радію, бо Спаситель -</a:t>
-            </a:r>
-            <a:endParaRPr lang="en-US" sz="4000" dirty="0"/>
-          </a:p>
-          <a:p>
-            <a:pPr algn="ctr" indent="0" marL="0">
-              <a:buNone/>
-            </a:pPr>
-            <a:r>
-              <a:rPr lang="en-US" sz="4000" b="1" i="1" dirty="0">
-                <a:solidFill>
-                  <a:srgbClr val="FFFFFF"/>
-                </a:solidFill>
-                <a:latin typeface="Arial" pitchFamily="34" charset="0"/>
-                <a:ea typeface="Arial" pitchFamily="34" charset="-122"/>
-                <a:cs typeface="Arial" pitchFamily="34" charset="-120"/>
-              </a:rPr>
-              <a:t>Джерело і Скарб душі моїй.</a:t>
-            </a:r>
-            <a:endParaRPr lang="en-US" sz="4000" dirty="0"/>
-          </a:p>
-          <a:p>
-            <a:pPr algn="ctr" indent="0" marL="0">
-              <a:buNone/>
-            </a:pPr>
-            <a:r>
-              <a:rPr lang="en-US" sz="4000" b="1" i="1" dirty="0">
-                <a:solidFill>
-                  <a:srgbClr val="FFFFFF"/>
-                </a:solidFill>
-                <a:latin typeface="Arial" pitchFamily="34" charset="0"/>
-                <a:ea typeface="Arial" pitchFamily="34" charset="-122"/>
-                <a:cs typeface="Arial" pitchFamily="34" charset="-120"/>
-              </a:rPr>
-              <a:t>Я Йому лиш довіряю –</a:t>
-            </a:r>
-            <a:endParaRPr lang="en-US" sz="4000" dirty="0"/>
-          </a:p>
-          <a:p>
-            <a:pPr algn="ctr" indent="0" marL="0">
-              <a:buNone/>
-            </a:pPr>
-            <a:r>
-              <a:rPr lang="en-US" sz="4000" b="1" i="1" dirty="0">
-                <a:solidFill>
-                  <a:srgbClr val="FFFFFF"/>
-                </a:solidFill>
-                <a:latin typeface="Arial" pitchFamily="34" charset="0"/>
-                <a:ea typeface="Arial" pitchFamily="34" charset="-122"/>
-                <a:cs typeface="Arial" pitchFamily="34" charset="-120"/>
-              </a:rPr>
-              <a:t>Спокій душа знайде лише в Христі!</a:t>
-            </a:r>
-            <a:endParaRPr lang="en-US" sz="4000" dirty="0"/>
+              <a:rPr lang="en-US" sz="4800" b="1" dirty="0">
+                <a:solidFill>
+                  <a:srgbClr val="FFFFFF"/>
+                </a:solidFill>
+                <a:latin typeface="Arial" pitchFamily="34" charset="0"/>
+                <a:ea typeface="Arial" pitchFamily="34" charset="-122"/>
+                <a:cs typeface="Arial" pitchFamily="34" charset="-120"/>
+              </a:rPr>
+              <a:t>Чим справді цінний Богу я?</a:t>
+            </a:r>
+            <a:endParaRPr lang="en-US" sz="4800" dirty="0"/>
+          </a:p>
+          <a:p>
+            <a:pPr algn="ctr" indent="0" marL="0">
+              <a:buNone/>
+            </a:pPr>
+            <a:r>
+              <a:rPr lang="en-US" sz="4800" b="1" dirty="0">
+                <a:solidFill>
+                  <a:srgbClr val="FFFFFF"/>
+                </a:solidFill>
+                <a:latin typeface="Arial" pitchFamily="34" charset="0"/>
+                <a:ea typeface="Arial" pitchFamily="34" charset="-122"/>
+                <a:cs typeface="Arial" pitchFamily="34" charset="-120"/>
+              </a:rPr>
+              <a:t>Ніщо – багатство чи краса.</a:t>
+            </a:r>
+            <a:endParaRPr lang="en-US" sz="4800" dirty="0"/>
+          </a:p>
+          <a:p>
+            <a:pPr algn="ctr" indent="0" marL="0">
+              <a:buNone/>
+            </a:pPr>
+            <a:r>
+              <a:rPr lang="en-US" sz="4800" b="1" dirty="0">
+                <a:solidFill>
+                  <a:srgbClr val="FFFFFF"/>
+                </a:solidFill>
+                <a:latin typeface="Arial" pitchFamily="34" charset="0"/>
+                <a:ea typeface="Arial" pitchFamily="34" charset="-122"/>
+                <a:cs typeface="Arial" pitchFamily="34" charset="-120"/>
+              </a:rPr>
+              <a:t>Христос пролив любов святу на хресті!</a:t>
+            </a:r>
+            <a:endParaRPr lang="en-US" sz="4800" dirty="0"/>
+          </a:p>
+          <a:p>
+            <a:pPr algn="ctr" indent="0" marL="0">
+              <a:buNone/>
+            </a:pPr>
+            <a:r>
+              <a:rPr lang="en-US" sz="4800" b="1" dirty="0">
+                <a:solidFill>
+                  <a:srgbClr val="FFFFFF"/>
+                </a:solidFill>
+                <a:latin typeface="Arial" pitchFamily="34" charset="0"/>
+                <a:ea typeface="Arial" pitchFamily="34" charset="-122"/>
+                <a:cs typeface="Arial" pitchFamily="34" charset="-120"/>
+              </a:rPr>
+              <a:t>Не маю слави у собі, y перемозі чи в біді</a:t>
+            </a:r>
+            <a:endParaRPr lang="en-US" sz="4800" dirty="0"/>
+          </a:p>
+          <a:p>
+            <a:pPr algn="ctr" indent="0" marL="0">
+              <a:buNone/>
+            </a:pPr>
+            <a:r>
+              <a:rPr lang="en-US" sz="4800" b="1" dirty="0">
+                <a:solidFill>
+                  <a:srgbClr val="FFFFFF"/>
+                </a:solidFill>
+                <a:latin typeface="Arial" pitchFamily="34" charset="0"/>
+                <a:ea typeface="Arial" pitchFamily="34" charset="-122"/>
+                <a:cs typeface="Arial" pitchFamily="34" charset="-120"/>
+              </a:rPr>
+              <a:t>Ісус за мене заплатив на хресті!</a:t>
+            </a:r>
+            <a:endParaRPr lang="en-US" sz="4800" dirty="0"/>
           </a:p>
         </p:txBody>
       </p:sp>
@@ -1695,85 +1733,68 @@
               <a:buNone/>
             </a:pPr>
             <a:r>
-              <a:rPr lang="en-US" sz="4000" b="1" dirty="0">
-                <a:solidFill>
-                  <a:srgbClr val="FFFFFF"/>
-                </a:solidFill>
-                <a:latin typeface="Arial" pitchFamily="34" charset="0"/>
-                <a:ea typeface="Arial" pitchFamily="34" charset="-122"/>
-                <a:cs typeface="Arial" pitchFamily="34" charset="-120"/>
-              </a:rPr>
-              <a:t>Ми в’янемо, немов трава, минають юність і краса.</a:t>
-            </a:r>
-            <a:endParaRPr lang="en-US" sz="4000" dirty="0"/>
-          </a:p>
-          <a:p>
-            <a:pPr algn="ctr" indent="0" marL="0">
-              <a:buNone/>
-            </a:pPr>
-            <a:r>
-              <a:rPr lang="en-US" sz="4000" b="1" dirty="0">
-                <a:solidFill>
-                  <a:srgbClr val="FFFFFF"/>
-                </a:solidFill>
-                <a:latin typeface="Arial" pitchFamily="34" charset="0"/>
-                <a:ea typeface="Arial" pitchFamily="34" charset="-122"/>
-                <a:cs typeface="Arial" pitchFamily="34" charset="-120"/>
-              </a:rPr>
-              <a:t>Бог каже вічності слова Із хреста</a:t>
-            </a:r>
-            <a:endParaRPr lang="en-US" sz="4000" dirty="0"/>
-          </a:p>
-          <a:p>
-            <a:pPr algn="ctr" indent="0" marL="0">
-              <a:buNone/>
-            </a:pPr>
-            <a:r>
-              <a:rPr lang="en-US" sz="4000" b="1" dirty="0">
-                <a:solidFill>
-                  <a:srgbClr val="FFFFFF"/>
-                </a:solidFill>
-                <a:latin typeface="Arial" pitchFamily="34" charset="0"/>
-                <a:ea typeface="Arial" pitchFamily="34" charset="-122"/>
-                <a:cs typeface="Arial" pitchFamily="34" charset="-120"/>
-              </a:rPr>
-              <a:t>Багатство й влада проминуть –</a:t>
-            </a:r>
-            <a:endParaRPr lang="en-US" sz="4000" dirty="0"/>
-          </a:p>
-          <a:p>
-            <a:pPr algn="ctr" indent="0" marL="0">
-              <a:buNone/>
-            </a:pPr>
-            <a:r>
-              <a:rPr lang="en-US" sz="4000" b="1" dirty="0">
-                <a:solidFill>
-                  <a:srgbClr val="FFFFFF"/>
-                </a:solidFill>
-                <a:latin typeface="Arial" pitchFamily="34" charset="0"/>
-                <a:ea typeface="Arial" pitchFamily="34" charset="-122"/>
-                <a:cs typeface="Arial" pitchFamily="34" charset="-120"/>
-              </a:rPr>
-              <a:t>У них шукає людство суть.</a:t>
-            </a:r>
-            <a:endParaRPr lang="en-US" sz="4000" dirty="0"/>
-          </a:p>
-          <a:p>
-            <a:pPr algn="ctr" indent="0" marL="0">
-              <a:buNone/>
-            </a:pPr>
-            <a:r>
-              <a:rPr lang="en-US" sz="4000" b="1" dirty="0">
-                <a:solidFill>
-                  <a:srgbClr val="FFFFFF"/>
-                </a:solidFill>
-                <a:latin typeface="Arial" pitchFamily="34" charset="0"/>
-                <a:ea typeface="Arial" pitchFamily="34" charset="-122"/>
-                <a:cs typeface="Arial" pitchFamily="34" charset="-120"/>
-              </a:rPr>
-              <a:t>Я хочу знати лиш Христа на хресті</a:t>
-            </a:r>
-            <a:endParaRPr lang="en-US" sz="4000" dirty="0"/>
+              <a:rPr lang="en-US" sz="4800" b="1" i="1" dirty="0">
+                <a:solidFill>
+                  <a:srgbClr val="FFFFFF"/>
+                </a:solidFill>
+                <a:latin typeface="Arial" pitchFamily="34" charset="0"/>
+                <a:ea typeface="Arial" pitchFamily="34" charset="-122"/>
+                <a:cs typeface="Arial" pitchFamily="34" charset="-120"/>
+              </a:rPr>
+              <a:t>Я радію, бо Спаситель -</a:t>
+            </a:r>
+            <a:endParaRPr lang="en-US" sz="4800" dirty="0"/>
+          </a:p>
+          <a:p>
+            <a:pPr algn="ctr" indent="0" marL="0">
+              <a:buNone/>
+            </a:pPr>
+            <a:r>
+              <a:rPr lang="en-US" sz="4800" b="1" i="1" dirty="0">
+                <a:solidFill>
+                  <a:srgbClr val="FFFFFF"/>
+                </a:solidFill>
+                <a:latin typeface="Arial" pitchFamily="34" charset="0"/>
+                <a:ea typeface="Arial" pitchFamily="34" charset="-122"/>
+                <a:cs typeface="Arial" pitchFamily="34" charset="-120"/>
+              </a:rPr>
+              <a:t>Джерело і Скарб душі моїй.</a:t>
+            </a:r>
+            <a:endParaRPr lang="en-US" sz="4800" dirty="0"/>
+          </a:p>
+          <a:p>
+            <a:pPr algn="ctr" indent="0" marL="0">
+              <a:buNone/>
+            </a:pPr>
+            <a:r>
+              <a:rPr lang="en-US" sz="4800" b="1" i="1" dirty="0">
+                <a:solidFill>
+                  <a:srgbClr val="FFFFFF"/>
+                </a:solidFill>
+                <a:latin typeface="Arial" pitchFamily="34" charset="0"/>
+                <a:ea typeface="Arial" pitchFamily="34" charset="-122"/>
+                <a:cs typeface="Arial" pitchFamily="34" charset="-120"/>
+              </a:rPr>
+              <a:t>Я Йому лиш довіряю –</a:t>
+            </a:r>
+            <a:endParaRPr lang="en-US" sz="4800" dirty="0"/>
+          </a:p>
+          <a:p>
+            <a:pPr algn="ctr" indent="0" marL="0">
+              <a:buNone/>
+            </a:pPr>
+            <a:r>
+              <a:rPr lang="en-US" sz="4800" b="1" i="1" dirty="0">
+                <a:solidFill>
+                  <a:srgbClr val="FFFFFF"/>
+                </a:solidFill>
+                <a:latin typeface="Arial" pitchFamily="34" charset="0"/>
+                <a:ea typeface="Arial" pitchFamily="34" charset="-122"/>
+                <a:cs typeface="Arial" pitchFamily="34" charset="-120"/>
+              </a:rPr>
+              <a:t>Спокій душа знайде лише в Христі!</a:t>
+            </a:r>
+            <a:endParaRPr lang="en-US" sz="4800" dirty="0"/>
           </a:p>
         </p:txBody>
       </p:sp>
@@ -1834,68 +1855,85 @@
               <a:buNone/>
             </a:pPr>
             <a:r>
-              <a:rPr lang="en-US" sz="4000" b="1" i="1" dirty="0">
-                <a:solidFill>
-                  <a:srgbClr val="FFFFFF"/>
-                </a:solidFill>
-                <a:latin typeface="Arial" pitchFamily="34" charset="0"/>
-                <a:ea typeface="Arial" pitchFamily="34" charset="-122"/>
-                <a:cs typeface="Arial" pitchFamily="34" charset="-120"/>
-              </a:rPr>
-              <a:t>Я радію, бо Спаситель -</a:t>
-            </a:r>
-            <a:endParaRPr lang="en-US" sz="4000" dirty="0"/>
-          </a:p>
-          <a:p>
-            <a:pPr algn="ctr" indent="0" marL="0">
-              <a:buNone/>
-            </a:pPr>
-            <a:r>
-              <a:rPr lang="en-US" sz="4000" b="1" i="1" dirty="0">
-                <a:solidFill>
-                  <a:srgbClr val="FFFFFF"/>
-                </a:solidFill>
-                <a:latin typeface="Arial" pitchFamily="34" charset="0"/>
-                <a:ea typeface="Arial" pitchFamily="34" charset="-122"/>
-                <a:cs typeface="Arial" pitchFamily="34" charset="-120"/>
-              </a:rPr>
-              <a:t>Джерело і Скарб душі моїй.</a:t>
-            </a:r>
-            <a:endParaRPr lang="en-US" sz="4000" dirty="0"/>
-          </a:p>
-          <a:p>
-            <a:pPr algn="ctr" indent="0" marL="0">
-              <a:buNone/>
-            </a:pPr>
-            <a:r>
-              <a:rPr lang="en-US" sz="4000" b="1" i="1" dirty="0">
-                <a:solidFill>
-                  <a:srgbClr val="FFFFFF"/>
-                </a:solidFill>
-                <a:latin typeface="Arial" pitchFamily="34" charset="0"/>
-                <a:ea typeface="Arial" pitchFamily="34" charset="-122"/>
-                <a:cs typeface="Arial" pitchFamily="34" charset="-120"/>
-              </a:rPr>
-              <a:t>Я Йому лиш довіряю –</a:t>
-            </a:r>
-            <a:endParaRPr lang="en-US" sz="4000" dirty="0"/>
-          </a:p>
-          <a:p>
-            <a:pPr algn="ctr" indent="0" marL="0">
-              <a:buNone/>
-            </a:pPr>
-            <a:r>
-              <a:rPr lang="en-US" sz="4000" b="1" i="1" dirty="0">
-                <a:solidFill>
-                  <a:srgbClr val="FFFFFF"/>
-                </a:solidFill>
-                <a:latin typeface="Arial" pitchFamily="34" charset="0"/>
-                <a:ea typeface="Arial" pitchFamily="34" charset="-122"/>
-                <a:cs typeface="Arial" pitchFamily="34" charset="-120"/>
-              </a:rPr>
-              <a:t>Спокій душа знайде лише в Христі!</a:t>
-            </a:r>
-            <a:endParaRPr lang="en-US" sz="4000" dirty="0"/>
+              <a:rPr lang="en-US" sz="4800" b="1" dirty="0">
+                <a:solidFill>
+                  <a:srgbClr val="FFFFFF"/>
+                </a:solidFill>
+                <a:latin typeface="Arial" pitchFamily="34" charset="0"/>
+                <a:ea typeface="Arial" pitchFamily="34" charset="-122"/>
+                <a:cs typeface="Arial" pitchFamily="34" charset="-120"/>
+              </a:rPr>
+              <a:t>Ми в’янемо, немов трава, минають юність і краса.</a:t>
+            </a:r>
+            <a:endParaRPr lang="en-US" sz="4800" dirty="0"/>
+          </a:p>
+          <a:p>
+            <a:pPr algn="ctr" indent="0" marL="0">
+              <a:buNone/>
+            </a:pPr>
+            <a:r>
+              <a:rPr lang="en-US" sz="4800" b="1" dirty="0">
+                <a:solidFill>
+                  <a:srgbClr val="FFFFFF"/>
+                </a:solidFill>
+                <a:latin typeface="Arial" pitchFamily="34" charset="0"/>
+                <a:ea typeface="Arial" pitchFamily="34" charset="-122"/>
+                <a:cs typeface="Arial" pitchFamily="34" charset="-120"/>
+              </a:rPr>
+              <a:t>Бог каже вічності слова Із хреста</a:t>
+            </a:r>
+            <a:endParaRPr lang="en-US" sz="4800" dirty="0"/>
+          </a:p>
+          <a:p>
+            <a:pPr algn="ctr" indent="0" marL="0">
+              <a:buNone/>
+            </a:pPr>
+            <a:r>
+              <a:rPr lang="en-US" sz="4800" b="1" dirty="0">
+                <a:solidFill>
+                  <a:srgbClr val="FFFFFF"/>
+                </a:solidFill>
+                <a:latin typeface="Arial" pitchFamily="34" charset="0"/>
+                <a:ea typeface="Arial" pitchFamily="34" charset="-122"/>
+                <a:cs typeface="Arial" pitchFamily="34" charset="-120"/>
+              </a:rPr>
+              <a:t>Багатство й влада проминуть –</a:t>
+            </a:r>
+            <a:endParaRPr lang="en-US" sz="4800" dirty="0"/>
+          </a:p>
+          <a:p>
+            <a:pPr algn="ctr" indent="0" marL="0">
+              <a:buNone/>
+            </a:pPr>
+            <a:r>
+              <a:rPr lang="en-US" sz="4800" b="1" dirty="0">
+                <a:solidFill>
+                  <a:srgbClr val="FFFFFF"/>
+                </a:solidFill>
+                <a:latin typeface="Arial" pitchFamily="34" charset="0"/>
+                <a:ea typeface="Arial" pitchFamily="34" charset="-122"/>
+                <a:cs typeface="Arial" pitchFamily="34" charset="-120"/>
+              </a:rPr>
+              <a:t>У них шукає людство суть.</a:t>
+            </a:r>
+            <a:endParaRPr lang="en-US" sz="4800" dirty="0"/>
+          </a:p>
+          <a:p>
+            <a:pPr algn="ctr" indent="0" marL="0">
+              <a:buNone/>
+            </a:pPr>
+            <a:r>
+              <a:rPr lang="en-US" sz="4800" b="1" dirty="0">
+                <a:solidFill>
+                  <a:srgbClr val="FFFFFF"/>
+                </a:solidFill>
+                <a:latin typeface="Arial" pitchFamily="34" charset="0"/>
+                <a:ea typeface="Arial" pitchFamily="34" charset="-122"/>
+                <a:cs typeface="Arial" pitchFamily="34" charset="-120"/>
+              </a:rPr>
+              <a:t>Я хочу знати лиш Христа на хресті</a:t>
+            </a:r>
+            <a:endParaRPr lang="en-US" sz="4800" dirty="0"/>
           </a:p>
         </p:txBody>
       </p:sp>
@@ -1956,51 +1994,68 @@
               <a:buNone/>
             </a:pPr>
             <a:r>
-              <a:rPr lang="en-US" sz="4000" b="1" dirty="0">
-                <a:solidFill>
-                  <a:srgbClr val="FFFFFF"/>
-                </a:solidFill>
-                <a:latin typeface="Arial" pitchFamily="34" charset="0"/>
-                <a:ea typeface="Arial" pitchFamily="34" charset="-122"/>
-                <a:cs typeface="Arial" pitchFamily="34" charset="-120"/>
-              </a:rPr>
-              <a:t>Я хочу всім розповісти:</a:t>
-            </a:r>
-            <a:endParaRPr lang="en-US" sz="4000" dirty="0"/>
-          </a:p>
-          <a:p>
-            <a:pPr algn="ctr" indent="0" marL="0">
-              <a:buNone/>
-            </a:pPr>
-            <a:r>
-              <a:rPr lang="en-US" sz="4000" b="1" dirty="0">
-                <a:solidFill>
-                  <a:srgbClr val="FFFFFF"/>
-                </a:solidFill>
-                <a:latin typeface="Arial" pitchFamily="34" charset="0"/>
-                <a:ea typeface="Arial" pitchFamily="34" charset="-122"/>
-                <a:cs typeface="Arial" pitchFamily="34" charset="-120"/>
-              </a:rPr>
-              <a:t>Ісус прийшов мене спасти.</a:t>
-            </a:r>
-            <a:endParaRPr lang="en-US" sz="4000" dirty="0"/>
-          </a:p>
-          <a:p>
-            <a:pPr algn="ctr" indent="0" marL="0">
-              <a:buNone/>
-            </a:pPr>
-            <a:r>
-              <a:rPr lang="en-US" sz="4000" b="1" dirty="0">
-                <a:solidFill>
-                  <a:srgbClr val="FFFFFF"/>
-                </a:solidFill>
-                <a:latin typeface="Arial" pitchFamily="34" charset="0"/>
-                <a:ea typeface="Arial" pitchFamily="34" charset="-122"/>
-                <a:cs typeface="Arial" pitchFamily="34" charset="-120"/>
-              </a:rPr>
-              <a:t>Він цінність дав душі моїй на хресті</a:t>
-            </a:r>
-            <a:endParaRPr lang="en-US" sz="4000" dirty="0"/>
+              <a:rPr lang="en-US" sz="4800" b="1" i="1" dirty="0">
+                <a:solidFill>
+                  <a:srgbClr val="FFFFFF"/>
+                </a:solidFill>
+                <a:latin typeface="Arial" pitchFamily="34" charset="0"/>
+                <a:ea typeface="Arial" pitchFamily="34" charset="-122"/>
+                <a:cs typeface="Arial" pitchFamily="34" charset="-120"/>
+              </a:rPr>
+              <a:t>Я радію, бо Спаситель -</a:t>
+            </a:r>
+            <a:endParaRPr lang="en-US" sz="4800" dirty="0"/>
+          </a:p>
+          <a:p>
+            <a:pPr algn="ctr" indent="0" marL="0">
+              <a:buNone/>
+            </a:pPr>
+            <a:r>
+              <a:rPr lang="en-US" sz="4800" b="1" i="1" dirty="0">
+                <a:solidFill>
+                  <a:srgbClr val="FFFFFF"/>
+                </a:solidFill>
+                <a:latin typeface="Arial" pitchFamily="34" charset="0"/>
+                <a:ea typeface="Arial" pitchFamily="34" charset="-122"/>
+                <a:cs typeface="Arial" pitchFamily="34" charset="-120"/>
+              </a:rPr>
+              <a:t>Джерело і Скарб душі моїй.</a:t>
+            </a:r>
+            <a:endParaRPr lang="en-US" sz="4800" dirty="0"/>
+          </a:p>
+          <a:p>
+            <a:pPr algn="ctr" indent="0" marL="0">
+              <a:buNone/>
+            </a:pPr>
+            <a:r>
+              <a:rPr lang="en-US" sz="4800" b="1" i="1" dirty="0">
+                <a:solidFill>
+                  <a:srgbClr val="FFFFFF"/>
+                </a:solidFill>
+                <a:latin typeface="Arial" pitchFamily="34" charset="0"/>
+                <a:ea typeface="Arial" pitchFamily="34" charset="-122"/>
+                <a:cs typeface="Arial" pitchFamily="34" charset="-120"/>
+              </a:rPr>
+              <a:t>Я Йому лиш довіряю –</a:t>
+            </a:r>
+            <a:endParaRPr lang="en-US" sz="4800" dirty="0"/>
+          </a:p>
+          <a:p>
+            <a:pPr algn="ctr" indent="0" marL="0">
+              <a:buNone/>
+            </a:pPr>
+            <a:r>
+              <a:rPr lang="en-US" sz="4800" b="1" i="1" dirty="0">
+                <a:solidFill>
+                  <a:srgbClr val="FFFFFF"/>
+                </a:solidFill>
+                <a:latin typeface="Arial" pitchFamily="34" charset="0"/>
+                <a:ea typeface="Arial" pitchFamily="34" charset="-122"/>
+                <a:cs typeface="Arial" pitchFamily="34" charset="-120"/>
+              </a:rPr>
+              <a:t>Спокій душа знайде лише в Христі!</a:t>
+            </a:r>
+            <a:endParaRPr lang="en-US" sz="4800" dirty="0"/>
           </a:p>
         </p:txBody>
       </p:sp>
@@ -2061,85 +2116,51 @@
               <a:buNone/>
             </a:pPr>
             <a:r>
-              <a:rPr lang="en-US" sz="4000" b="1" i="1" dirty="0">
-                <a:solidFill>
-                  <a:srgbClr val="FFFFFF"/>
-                </a:solidFill>
-                <a:latin typeface="Arial" pitchFamily="34" charset="0"/>
-                <a:ea typeface="Arial" pitchFamily="34" charset="-122"/>
-                <a:cs typeface="Arial" pitchFamily="34" charset="-120"/>
-              </a:rPr>
-              <a:t>Я радію, бо Спаситель -</a:t>
-            </a:r>
-            <a:endParaRPr lang="en-US" sz="4000" dirty="0"/>
-          </a:p>
-          <a:p>
-            <a:pPr algn="ctr" indent="0" marL="0">
-              <a:buNone/>
-            </a:pPr>
-            <a:r>
-              <a:rPr lang="en-US" sz="4000" b="1" i="1" dirty="0">
-                <a:solidFill>
-                  <a:srgbClr val="FFFFFF"/>
-                </a:solidFill>
-                <a:latin typeface="Arial" pitchFamily="34" charset="0"/>
-                <a:ea typeface="Arial" pitchFamily="34" charset="-122"/>
-                <a:cs typeface="Arial" pitchFamily="34" charset="-120"/>
-              </a:rPr>
-              <a:t>Джерело і Скарб душі моїй.</a:t>
-            </a:r>
-            <a:endParaRPr lang="en-US" sz="4000" dirty="0"/>
-          </a:p>
-          <a:p>
-            <a:pPr algn="ctr" indent="0" marL="0">
-              <a:buNone/>
-            </a:pPr>
-            <a:r>
-              <a:rPr lang="en-US" sz="4000" b="1" i="1" dirty="0">
-                <a:solidFill>
-                  <a:srgbClr val="FFFFFF"/>
-                </a:solidFill>
-                <a:latin typeface="Arial" pitchFamily="34" charset="0"/>
-                <a:ea typeface="Arial" pitchFamily="34" charset="-122"/>
-                <a:cs typeface="Arial" pitchFamily="34" charset="-120"/>
-              </a:rPr>
-              <a:t>Я Йому лиш довіряю –</a:t>
-            </a:r>
-            <a:endParaRPr lang="en-US" sz="4000" dirty="0"/>
-          </a:p>
-          <a:p>
-            <a:pPr algn="ctr" indent="0" marL="0">
-              <a:buNone/>
-            </a:pPr>
-            <a:r>
-              <a:rPr lang="en-US" sz="4000" b="1" i="1" dirty="0">
-                <a:solidFill>
-                  <a:srgbClr val="FFFFFF"/>
-                </a:solidFill>
-                <a:latin typeface="Arial" pitchFamily="34" charset="0"/>
-                <a:ea typeface="Arial" pitchFamily="34" charset="-122"/>
-                <a:cs typeface="Arial" pitchFamily="34" charset="-120"/>
-              </a:rPr>
-              <a:t>Спокій душа знайде лише в Христі!</a:t>
-            </a:r>
-            <a:endParaRPr lang="en-US" sz="4000" dirty="0"/>
-          </a:p>
-          <a:p>
-            <a:pPr algn="ctr" indent="0" marL="0">
-              <a:buNone/>
-            </a:pPr>
-            <a:r>
-              <a:rPr lang="en-US" sz="4000" b="1" i="1" dirty="0">
-                <a:solidFill>
-                  <a:srgbClr val="FFFFFF"/>
-                </a:solidFill>
-                <a:latin typeface="Arial" pitchFamily="34" charset="0"/>
-                <a:ea typeface="Arial" pitchFamily="34" charset="-122"/>
-                <a:cs typeface="Arial" pitchFamily="34" charset="-120"/>
-              </a:rPr>
-              <a:t>Я радію, бо Спаситель -</a:t>
-            </a:r>
-            <a:endParaRPr lang="en-US" sz="4000" dirty="0"/>
+              <a:rPr lang="en-US" sz="4800" b="1" dirty="0">
+                <a:solidFill>
+                  <a:srgbClr val="FFFFFF"/>
+                </a:solidFill>
+                <a:latin typeface="Arial" pitchFamily="34" charset="0"/>
+                <a:ea typeface="Arial" pitchFamily="34" charset="-122"/>
+                <a:cs typeface="Arial" pitchFamily="34" charset="-120"/>
+              </a:rPr>
+              <a:t>Я хочу всім розповісти:</a:t>
+            </a:r>
+            <a:endParaRPr lang="en-US" sz="4800" dirty="0"/>
+          </a:p>
+          <a:p>
+            <a:pPr algn="ctr" indent="0" marL="0">
+              <a:buNone/>
+            </a:pPr>
+            <a:r>
+              <a:rPr lang="en-US" sz="4800" b="1" dirty="0">
+                <a:solidFill>
+                  <a:srgbClr val="FFFFFF"/>
+                </a:solidFill>
+                <a:latin typeface="Arial" pitchFamily="34" charset="0"/>
+                <a:ea typeface="Arial" pitchFamily="34" charset="-122"/>
+                <a:cs typeface="Arial" pitchFamily="34" charset="-120"/>
+              </a:rPr>
+              <a:t>Ісус прийшов мене спасти.</a:t>
+            </a:r>
+            <a:endParaRPr lang="en-US" sz="4800" dirty="0"/>
+          </a:p>
+          <a:p>
+            <a:pPr algn="ctr" indent="0" marL="0">
+              <a:buNone/>
+            </a:pPr>
+            <a:r>
+              <a:rPr lang="en-US" sz="4800" b="1" dirty="0">
+                <a:solidFill>
+                  <a:srgbClr val="FFFFFF"/>
+                </a:solidFill>
+                <a:latin typeface="Arial" pitchFamily="34" charset="0"/>
+                <a:ea typeface="Arial" pitchFamily="34" charset="-122"/>
+                <a:cs typeface="Arial" pitchFamily="34" charset="-120"/>
+              </a:rPr>
+              <a:t>Він цінність дав душі моїй на хресті</a:t>
+            </a:r>
+            <a:endParaRPr lang="en-US" sz="4800" dirty="0"/>
           </a:p>
         </p:txBody>
       </p:sp>
@@ -2200,7 +2221,24 @@
               <a:buNone/>
             </a:pPr>
             <a:r>
-              <a:rPr lang="en-US" sz="4000" b="1" i="1" dirty="0">
+              <a:rPr lang="en-US" sz="4800" b="1" i="1" dirty="0">
+                <a:solidFill>
+                  <a:srgbClr val="FFFFFF"/>
+                </a:solidFill>
+                <a:latin typeface="Arial" pitchFamily="34" charset="0"/>
+                <a:ea typeface="Arial" pitchFamily="34" charset="-122"/>
+                <a:cs typeface="Arial" pitchFamily="34" charset="-120"/>
+              </a:rPr>
+              <a:t>Я радію, бо Спаситель -</a:t>
+            </a:r>
+            <a:endParaRPr lang="en-US" sz="4800" dirty="0"/>
+          </a:p>
+          <a:p>
+            <a:pPr algn="ctr" indent="0" marL="0">
+              <a:buNone/>
+            </a:pPr>
+            <a:r>
+              <a:rPr lang="en-US" sz="4800" b="1" i="1" dirty="0">
                 <a:solidFill>
                   <a:srgbClr val="FFFFFF"/>
                 </a:solidFill>
@@ -2210,14 +2248,14 @@
               </a:rPr>
               <a:t>Джерело і Скарб душі моїй.</a:t>
             </a:r>
-            <a:endParaRPr lang="en-US" sz="4000" dirty="0"/>
-          </a:p>
-          <a:p>
-            <a:pPr algn="ctr" indent="0" marL="0">
-              <a:buNone/>
-            </a:pPr>
-            <a:r>
-              <a:rPr lang="en-US" sz="4000" b="1" i="1" dirty="0">
+            <a:endParaRPr lang="en-US" sz="4800" dirty="0"/>
+          </a:p>
+          <a:p>
+            <a:pPr algn="ctr" indent="0" marL="0">
+              <a:buNone/>
+            </a:pPr>
+            <a:r>
+              <a:rPr lang="en-US" sz="4800" b="1" i="1" dirty="0">
                 <a:solidFill>
                   <a:srgbClr val="FFFFFF"/>
                 </a:solidFill>
@@ -2227,14 +2265,14 @@
               </a:rPr>
               <a:t>Я Йому лиш довіряю –</a:t>
             </a:r>
-            <a:endParaRPr lang="en-US" sz="4000" dirty="0"/>
-          </a:p>
-          <a:p>
-            <a:pPr algn="ctr" indent="0" marL="0">
-              <a:buNone/>
-            </a:pPr>
-            <a:r>
-              <a:rPr lang="en-US" sz="4000" b="1" i="1" dirty="0">
+            <a:endParaRPr lang="en-US" sz="4800" dirty="0"/>
+          </a:p>
+          <a:p>
+            <a:pPr algn="ctr" indent="0" marL="0">
+              <a:buNone/>
+            </a:pPr>
+            <a:r>
+              <a:rPr lang="en-US" sz="4800" b="1" i="1" dirty="0">
                 <a:solidFill>
                   <a:srgbClr val="FFFFFF"/>
                 </a:solidFill>
@@ -2244,14 +2282,119 @@
               </a:rPr>
               <a:t>Спокій душа знайде лише в Христі!</a:t>
             </a:r>
-            <a:endParaRPr lang="en-US" sz="4000" dirty="0"/>
-          </a:p>
-          <a:p>
-            <a:pPr algn="ctr" indent="0" marL="0">
-              <a:buNone/>
-            </a:pPr>
-            <a:r>
-              <a:rPr lang="en-US" sz="4000" b="1" i="1" dirty="0">
+            <a:endParaRPr lang="en-US" sz="4800" dirty="0"/>
+          </a:p>
+        </p:txBody>
+      </p:sp>
+    </p:spTree>
+  </p:cSld>
+  <p:clrMapOvr>
+    <a:masterClrMapping/>
+  </p:clrMapOvr>
+</p:sld>
+</file>
+
+<file path=ppt/slides/slide8.xml><?xml version="1.0" encoding="utf-8"?>
+<p:sld xmlns:a="http://schemas.openxmlformats.org/drawingml/2006/main" xmlns:r="http://schemas.openxmlformats.org/officeDocument/2006/relationships" xmlns:p="http://schemas.openxmlformats.org/presentationml/2006/main">
+  <p:cSld name="Slide 8">
+    <p:bg>
+      <p:bgPr>
+        <a:solidFill>
+          <a:srgbClr val="000000"/>
+        </a:solidFill>
+      </p:bgPr>
+    </p:bg>
+    <p:spTree>
+      <p:nvGrpSpPr>
+        <p:cNvPr id="1" name=""/>
+        <p:cNvGrpSpPr/>
+        <p:nvPr/>
+      </p:nvGrpSpPr>
+      <p:grpSpPr>
+        <a:xfrm>
+          <a:off x="0" y="0"/>
+          <a:ext cx="0" cy="0"/>
+          <a:chOff x="0" y="0"/>
+          <a:chExt cx="0" cy="0"/>
+        </a:xfrm>
+      </p:grpSpPr>
+      <p:sp>
+        <p:nvSpPr>
+          <p:cNvPr id="2" name="Text 0"/>
+          <p:cNvSpPr txBox="1"/>
+          <p:nvPr/>
+        </p:nvSpPr>
+        <p:spPr>
+          <a:xfrm>
+            <a:off x="548640" y="457200"/>
+            <a:ext cx="11064240" cy="5943600"/>
+          </a:xfrm>
+          <a:prstGeom prst="rect">
+            <a:avLst/>
+          </a:prstGeom>
+          <a:noFill/>
+          <a:ln/>
+        </p:spPr>
+        <p:txBody>
+          <a:bodyPr wrap="square" lIns="0" tIns="0" rIns="0" bIns="0" rtlCol="0" anchor="ctr"/>
+          <a:lstStyle/>
+          <a:p>
+            <a:pPr algn="ctr" indent="0" marL="0">
+              <a:buNone/>
+            </a:pPr>
+            <a:r>
+              <a:rPr lang="en-US" sz="4800" b="1" i="1" dirty="0">
+                <a:solidFill>
+                  <a:srgbClr val="FFFFFF"/>
+                </a:solidFill>
+                <a:latin typeface="Arial" pitchFamily="34" charset="0"/>
+                <a:ea typeface="Arial" pitchFamily="34" charset="-122"/>
+                <a:cs typeface="Arial" pitchFamily="34" charset="-120"/>
+              </a:rPr>
+              <a:t>Я радію, бо Спаситель -</a:t>
+            </a:r>
+            <a:endParaRPr lang="en-US" sz="4800" dirty="0"/>
+          </a:p>
+          <a:p>
+            <a:pPr algn="ctr" indent="0" marL="0">
+              <a:buNone/>
+            </a:pPr>
+            <a:r>
+              <a:rPr lang="en-US" sz="4800" b="1" i="1" dirty="0">
+                <a:solidFill>
+                  <a:srgbClr val="FFFFFF"/>
+                </a:solidFill>
+                <a:latin typeface="Arial" pitchFamily="34" charset="0"/>
+                <a:ea typeface="Arial" pitchFamily="34" charset="-122"/>
+                <a:cs typeface="Arial" pitchFamily="34" charset="-120"/>
+              </a:rPr>
+              <a:t>Джерело і Скарб душі моїй.</a:t>
+            </a:r>
+            <a:endParaRPr lang="en-US" sz="4800" dirty="0"/>
+          </a:p>
+          <a:p>
+            <a:pPr algn="ctr" indent="0" marL="0">
+              <a:buNone/>
+            </a:pPr>
+            <a:r>
+              <a:rPr lang="en-US" sz="4800" b="1" i="1" dirty="0">
+                <a:solidFill>
+                  <a:srgbClr val="FFFFFF"/>
+                </a:solidFill>
+                <a:latin typeface="Arial" pitchFamily="34" charset="0"/>
+                <a:ea typeface="Arial" pitchFamily="34" charset="-122"/>
+                <a:cs typeface="Arial" pitchFamily="34" charset="-120"/>
+              </a:rPr>
+              <a:t>Я Йому лиш довіряю –</a:t>
+            </a:r>
+            <a:endParaRPr lang="en-US" sz="4800" dirty="0"/>
+          </a:p>
+          <a:p>
+            <a:pPr algn="ctr" indent="0" marL="0">
+              <a:buNone/>
+            </a:pPr>
+            <a:r>
+              <a:rPr lang="en-US" sz="4800" b="1" i="1" dirty="0">
                 <a:solidFill>
                   <a:srgbClr val="FFFFFF"/>
                 </a:solidFill>
@@ -2261,14 +2404,31 @@
               </a:rPr>
               <a:t>Спокій душа знайде лише в Христі!</a:t>
             </a:r>
-            <a:endParaRPr lang="en-US" sz="4000" dirty="0"/>
-          </a:p>
-          <a:p>
-            <a:pPr algn="ctr" indent="0" marL="0">
-              <a:buNone/>
-            </a:pPr>
-            <a:r>
-              <a:rPr lang="en-US" sz="4000" b="1" i="1" dirty="0">
+            <a:endParaRPr lang="en-US" sz="4800" dirty="0"/>
+          </a:p>
+          <a:p>
+            <a:pPr algn="ctr" indent="0" marL="0">
+              <a:buNone/>
+            </a:pPr>
+            <a:r>
+              <a:rPr lang="en-US" sz="4800" b="1" i="1" dirty="0">
+                <a:solidFill>
+                  <a:srgbClr val="FFFFFF"/>
+                </a:solidFill>
+                <a:latin typeface="Arial" pitchFamily="34" charset="0"/>
+                <a:ea typeface="Arial" pitchFamily="34" charset="-122"/>
+                <a:cs typeface="Arial" pitchFamily="34" charset="-120"/>
+              </a:rPr>
+              <a:t>Спокій душа знайде лише в Христі!</a:t>
+            </a:r>
+            <a:endParaRPr lang="en-US" sz="4800" dirty="0"/>
+          </a:p>
+          <a:p>
+            <a:pPr algn="ctr" indent="0" marL="0">
+              <a:buNone/>
+            </a:pPr>
+            <a:r>
+              <a:rPr lang="en-US" sz="4800" b="1" i="1" dirty="0">
                 <a:solidFill>
                   <a:srgbClr val="FFFFFF"/>
                 </a:solidFill>
@@ -2278,7 +2438,7 @@
               </a:rPr>
               <a:t>***</a:t>
             </a:r>
-            <a:endParaRPr lang="en-US" sz="4000" dirty="0"/>
+            <a:endParaRPr lang="en-US" sz="4800" dirty="0"/>
           </a:p>
         </p:txBody>
       </p:sp>

</xml_diff>

<commit_message>
Update PowerPoint for song #2 in FUBC - Українські
</commit_message>
<xml_diff>
--- a/fubc-ua/2-Чим справді цінний Богу я (My Worth Is Not In What I Own).pptx
+++ b/fubc-ua/2-Чим справді цінний Богу я (My Worth Is Not In What I Own).pptx
@@ -13,9 +13,12 @@
     <p:sldId id="261" r:id="rId7"/>
     <p:sldId id="262" r:id="rId8"/>
     <p:sldId id="263" r:id="rId9"/>
+    <p:sldId id="264" r:id="rId10"/>
+    <p:sldId id="265" r:id="rId11"/>
+    <p:sldId id="266" r:id="rId12"/>
   </p:sldIdLst>
   <p:notesMasterIdLst>
-    <p:notesMasterId r:id="rId10"/>
+    <p:notesMasterId r:id="rId13"/>
   </p:notesMasterIdLst>
   <p:sldSz cx="12192000" cy="6858000"/>
   <p:notesSz cx="6858000" cy="12192000"/>
@@ -551,6 +554,182 @@
 </p:notes>
 </file>
 
+<file path=ppt/notesSlides/notesSlide10.xml><?xml version="1.0" encoding="utf-8"?>
+<p:notes xmlns:a="http://schemas.openxmlformats.org/drawingml/2006/main" xmlns:r="http://schemas.openxmlformats.org/officeDocument/2006/relationships" xmlns:p="http://schemas.openxmlformats.org/presentationml/2006/main">
+  <p:cSld>
+    <p:spTree>
+      <p:nvGrpSpPr>
+        <p:cNvPr id="1" name=""/>
+        <p:cNvGrpSpPr/>
+        <p:nvPr/>
+      </p:nvGrpSpPr>
+      <p:grpSpPr>
+        <a:xfrm>
+          <a:off x="0" y="0"/>
+          <a:ext cx="0" cy="0"/>
+          <a:chOff x="0" y="0"/>
+          <a:chExt cx="0" cy="0"/>
+        </a:xfrm>
+      </p:grpSpPr>
+      <p:sp>
+        <p:nvSpPr>
+          <p:cNvPr id="2" name="Slide Image Placeholder 1"/>
+          <p:cNvSpPr>
+            <a:spLocks noGrp="1" noRot="1" noChangeAspect="1"/>
+          </p:cNvSpPr>
+          <p:nvPr>
+            <p:ph type="sldImg"/>
+          </p:nvPr>
+        </p:nvSpPr>
+        <p:spPr/>
+      </p:sp>
+      <p:sp>
+        <p:nvSpPr>
+          <p:cNvPr id="3" name="Notes Placeholder 2"/>
+          <p:cNvSpPr>
+            <a:spLocks noGrp="1"/>
+          </p:cNvSpPr>
+          <p:nvPr>
+            <p:ph type="body" idx="1"/>
+          </p:nvPr>
+        </p:nvSpPr>
+        <p:spPr/>
+        <p:txBody>
+          <a:bodyPr/>
+          <a:lstStyle/>
+          <a:p>
+            <a:r>
+              <a:rPr lang="en-US" dirty="0"/>
+              <a:t/>
+            </a:r>
+            <a:endParaRPr lang="en-US" dirty="0"/>
+          </a:p>
+        </p:txBody>
+      </p:sp>
+      <p:sp>
+        <p:nvSpPr>
+          <p:cNvPr id="4" name="Slide Number Placeholder 3"/>
+          <p:cNvSpPr>
+            <a:spLocks noGrp="1"/>
+          </p:cNvSpPr>
+          <p:nvPr>
+            <p:ph type="sldNum" sz="quarter" idx="10"/>
+          </p:nvPr>
+        </p:nvSpPr>
+        <p:spPr/>
+        <p:txBody>
+          <a:bodyPr/>
+          <a:lstStyle/>
+          <a:p>
+            <a:fld id="{F7021451-1387-4CA6-816F-3879F97B5CBC}" type="slidenum">
+              <a:rPr lang="en-US"/>
+              <a:t>10</a:t>
+            </a:fld>
+            <a:endParaRPr lang="en-US"/>
+          </a:p>
+        </p:txBody>
+      </p:sp>
+    </p:spTree>
+    <p:extLst>
+      <p:ext uri="{BB962C8B-B14F-4D97-AF65-F5344CB8AC3E}">
+        <p14:creationId xmlns:p14="http://schemas.microsoft.com/office/powerpoint/2010/main" val="1024086991"/>
+      </p:ext>
+    </p:extLst>
+  </p:cSld>
+  <p:clrMapOvr>
+    <a:masterClrMapping/>
+  </p:clrMapOvr>
+</p:notes>
+</file>
+
+<file path=ppt/notesSlides/notesSlide11.xml><?xml version="1.0" encoding="utf-8"?>
+<p:notes xmlns:a="http://schemas.openxmlformats.org/drawingml/2006/main" xmlns:r="http://schemas.openxmlformats.org/officeDocument/2006/relationships" xmlns:p="http://schemas.openxmlformats.org/presentationml/2006/main">
+  <p:cSld>
+    <p:spTree>
+      <p:nvGrpSpPr>
+        <p:cNvPr id="1" name=""/>
+        <p:cNvGrpSpPr/>
+        <p:nvPr/>
+      </p:nvGrpSpPr>
+      <p:grpSpPr>
+        <a:xfrm>
+          <a:off x="0" y="0"/>
+          <a:ext cx="0" cy="0"/>
+          <a:chOff x="0" y="0"/>
+          <a:chExt cx="0" cy="0"/>
+        </a:xfrm>
+      </p:grpSpPr>
+      <p:sp>
+        <p:nvSpPr>
+          <p:cNvPr id="2" name="Slide Image Placeholder 1"/>
+          <p:cNvSpPr>
+            <a:spLocks noGrp="1" noRot="1" noChangeAspect="1"/>
+          </p:cNvSpPr>
+          <p:nvPr>
+            <p:ph type="sldImg"/>
+          </p:nvPr>
+        </p:nvSpPr>
+        <p:spPr/>
+      </p:sp>
+      <p:sp>
+        <p:nvSpPr>
+          <p:cNvPr id="3" name="Notes Placeholder 2"/>
+          <p:cNvSpPr>
+            <a:spLocks noGrp="1"/>
+          </p:cNvSpPr>
+          <p:nvPr>
+            <p:ph type="body" idx="1"/>
+          </p:nvPr>
+        </p:nvSpPr>
+        <p:spPr/>
+        <p:txBody>
+          <a:bodyPr/>
+          <a:lstStyle/>
+          <a:p>
+            <a:r>
+              <a:rPr lang="en-US" dirty="0"/>
+              <a:t/>
+            </a:r>
+            <a:endParaRPr lang="en-US" dirty="0"/>
+          </a:p>
+        </p:txBody>
+      </p:sp>
+      <p:sp>
+        <p:nvSpPr>
+          <p:cNvPr id="4" name="Slide Number Placeholder 3"/>
+          <p:cNvSpPr>
+            <a:spLocks noGrp="1"/>
+          </p:cNvSpPr>
+          <p:nvPr>
+            <p:ph type="sldNum" sz="quarter" idx="10"/>
+          </p:nvPr>
+        </p:nvSpPr>
+        <p:spPr/>
+        <p:txBody>
+          <a:bodyPr/>
+          <a:lstStyle/>
+          <a:p>
+            <a:fld id="{F7021451-1387-4CA6-816F-3879F97B5CBC}" type="slidenum">
+              <a:rPr lang="en-US"/>
+              <a:t>11</a:t>
+            </a:fld>
+            <a:endParaRPr lang="en-US"/>
+          </a:p>
+        </p:txBody>
+      </p:sp>
+    </p:spTree>
+    <p:extLst>
+      <p:ext uri="{BB962C8B-B14F-4D97-AF65-F5344CB8AC3E}">
+        <p14:creationId xmlns:p14="http://schemas.microsoft.com/office/powerpoint/2010/main" val="1024086991"/>
+      </p:ext>
+    </p:extLst>
+  </p:cSld>
+  <p:clrMapOvr>
+    <a:masterClrMapping/>
+  </p:clrMapOvr>
+</p:notes>
+</file>
+
 <file path=ppt/notesSlides/notesSlide2.xml><?xml version="1.0" encoding="utf-8"?>
 <p:notes xmlns:a="http://schemas.openxmlformats.org/drawingml/2006/main" xmlns:r="http://schemas.openxmlformats.org/officeDocument/2006/relationships" xmlns:p="http://schemas.openxmlformats.org/presentationml/2006/main">
   <p:cSld>
@@ -1149,6 +1328,94 @@
             <a:fld id="{F7021451-1387-4CA6-816F-3879F97B5CBC}" type="slidenum">
               <a:rPr lang="en-US"/>
               <a:t>8</a:t>
+            </a:fld>
+            <a:endParaRPr lang="en-US"/>
+          </a:p>
+        </p:txBody>
+      </p:sp>
+    </p:spTree>
+    <p:extLst>
+      <p:ext uri="{BB962C8B-B14F-4D97-AF65-F5344CB8AC3E}">
+        <p14:creationId xmlns:p14="http://schemas.microsoft.com/office/powerpoint/2010/main" val="1024086991"/>
+      </p:ext>
+    </p:extLst>
+  </p:cSld>
+  <p:clrMapOvr>
+    <a:masterClrMapping/>
+  </p:clrMapOvr>
+</p:notes>
+</file>
+
+<file path=ppt/notesSlides/notesSlide9.xml><?xml version="1.0" encoding="utf-8"?>
+<p:notes xmlns:a="http://schemas.openxmlformats.org/drawingml/2006/main" xmlns:r="http://schemas.openxmlformats.org/officeDocument/2006/relationships" xmlns:p="http://schemas.openxmlformats.org/presentationml/2006/main">
+  <p:cSld>
+    <p:spTree>
+      <p:nvGrpSpPr>
+        <p:cNvPr id="1" name=""/>
+        <p:cNvGrpSpPr/>
+        <p:nvPr/>
+      </p:nvGrpSpPr>
+      <p:grpSpPr>
+        <a:xfrm>
+          <a:off x="0" y="0"/>
+          <a:ext cx="0" cy="0"/>
+          <a:chOff x="0" y="0"/>
+          <a:chExt cx="0" cy="0"/>
+        </a:xfrm>
+      </p:grpSpPr>
+      <p:sp>
+        <p:nvSpPr>
+          <p:cNvPr id="2" name="Slide Image Placeholder 1"/>
+          <p:cNvSpPr>
+            <a:spLocks noGrp="1" noRot="1" noChangeAspect="1"/>
+          </p:cNvSpPr>
+          <p:nvPr>
+            <p:ph type="sldImg"/>
+          </p:nvPr>
+        </p:nvSpPr>
+        <p:spPr/>
+      </p:sp>
+      <p:sp>
+        <p:nvSpPr>
+          <p:cNvPr id="3" name="Notes Placeholder 2"/>
+          <p:cNvSpPr>
+            <a:spLocks noGrp="1"/>
+          </p:cNvSpPr>
+          <p:nvPr>
+            <p:ph type="body" idx="1"/>
+          </p:nvPr>
+        </p:nvSpPr>
+        <p:spPr/>
+        <p:txBody>
+          <a:bodyPr/>
+          <a:lstStyle/>
+          <a:p>
+            <a:r>
+              <a:rPr lang="en-US" dirty="0"/>
+              <a:t/>
+            </a:r>
+            <a:endParaRPr lang="en-US" dirty="0"/>
+          </a:p>
+        </p:txBody>
+      </p:sp>
+      <p:sp>
+        <p:nvSpPr>
+          <p:cNvPr id="4" name="Slide Number Placeholder 3"/>
+          <p:cNvSpPr>
+            <a:spLocks noGrp="1"/>
+          </p:cNvSpPr>
+          <p:nvPr>
+            <p:ph type="sldNum" sz="quarter" idx="10"/>
+          </p:nvPr>
+        </p:nvSpPr>
+        <p:spPr/>
+        <p:txBody>
+          <a:bodyPr/>
+          <a:lstStyle/>
+          <a:p>
+            <a:fld id="{F7021451-1387-4CA6-816F-3879F97B5CBC}" type="slidenum">
+              <a:rPr lang="en-US"/>
+              <a:t>9</a:t>
             </a:fld>
             <a:endParaRPr lang="en-US"/>
           </a:p>
@@ -1523,17 +1790,284 @@
               <a:buNone/>
             </a:pPr>
             <a:r>
-              <a:rPr lang="en-US" sz="4800" b="1" dirty="0">
-                <a:solidFill>
-                  <a:srgbClr val="FFFFFF"/>
-                </a:solidFill>
-                <a:latin typeface="Arial" pitchFamily="34" charset="0"/>
-                <a:ea typeface="Arial" pitchFamily="34" charset="-122"/>
-                <a:cs typeface="Arial" pitchFamily="34" charset="-120"/>
-              </a:rPr>
-              <a:t>Чим справді цінний Богу я? (My Worth Is Not In What I Own)</a:t>
-            </a:r>
-            <a:endParaRPr lang="en-US" sz="4800" dirty="0"/>
+              <a:rPr lang="en-US" sz="4700" b="1" dirty="0">
+                <a:solidFill>
+                  <a:srgbClr val="FFFFFF"/>
+                </a:solidFill>
+                <a:latin typeface="Arial" pitchFamily="34" charset="0"/>
+                <a:ea typeface="Arial" pitchFamily="34" charset="-122"/>
+                <a:cs typeface="Arial" pitchFamily="34" charset="-120"/>
+              </a:rPr>
+              <a:t>Чим справді цінний Богу я? </a:t>
+            </a:r>
+            <a:endParaRPr lang="en-US" sz="4700" dirty="0"/>
+          </a:p>
+          <a:p>
+            <a:pPr algn="ctr" indent="0" marL="0">
+              <a:buNone/>
+            </a:pPr>
+            <a:r>
+              <a:rPr lang="en-US" sz="4700" b="1" dirty="0">
+                <a:solidFill>
+                  <a:srgbClr val="FFFFFF"/>
+                </a:solidFill>
+                <a:latin typeface="Arial" pitchFamily="34" charset="0"/>
+                <a:ea typeface="Arial" pitchFamily="34" charset="-122"/>
+                <a:cs typeface="Arial" pitchFamily="34" charset="-120"/>
+              </a:rPr>
+              <a:t>(My Worth Is Not In What I Own)</a:t>
+            </a:r>
+            <a:endParaRPr lang="en-US" sz="4700" dirty="0"/>
+          </a:p>
+        </p:txBody>
+      </p:sp>
+    </p:spTree>
+  </p:cSld>
+  <p:clrMapOvr>
+    <a:masterClrMapping/>
+  </p:clrMapOvr>
+</p:sld>
+</file>
+
+<file path=ppt/slides/slide10.xml><?xml version="1.0" encoding="utf-8"?>
+<p:sld xmlns:a="http://schemas.openxmlformats.org/drawingml/2006/main" xmlns:r="http://schemas.openxmlformats.org/officeDocument/2006/relationships" xmlns:p="http://schemas.openxmlformats.org/presentationml/2006/main">
+  <p:cSld name="Slide 10">
+    <p:bg>
+      <p:bgPr>
+        <a:solidFill>
+          <a:srgbClr val="000000"/>
+        </a:solidFill>
+      </p:bgPr>
+    </p:bg>
+    <p:spTree>
+      <p:nvGrpSpPr>
+        <p:cNvPr id="1" name=""/>
+        <p:cNvGrpSpPr/>
+        <p:nvPr/>
+      </p:nvGrpSpPr>
+      <p:grpSpPr>
+        <a:xfrm>
+          <a:off x="0" y="0"/>
+          <a:ext cx="0" cy="0"/>
+          <a:chOff x="0" y="0"/>
+          <a:chExt cx="0" cy="0"/>
+        </a:xfrm>
+      </p:grpSpPr>
+      <p:sp>
+        <p:nvSpPr>
+          <p:cNvPr id="2" name="Text 0"/>
+          <p:cNvSpPr txBox="1"/>
+          <p:nvPr/>
+        </p:nvSpPr>
+        <p:spPr>
+          <a:xfrm>
+            <a:off x="548640" y="457200"/>
+            <a:ext cx="11064240" cy="5943600"/>
+          </a:xfrm>
+          <a:prstGeom prst="rect">
+            <a:avLst/>
+          </a:prstGeom>
+          <a:noFill/>
+          <a:ln/>
+        </p:spPr>
+        <p:txBody>
+          <a:bodyPr wrap="square" lIns="0" tIns="0" rIns="0" bIns="0" rtlCol="0" anchor="ctr"/>
+          <a:lstStyle/>
+          <a:p>
+            <a:pPr algn="ctr" indent="0" marL="0">
+              <a:buNone/>
+            </a:pPr>
+            <a:r>
+              <a:rPr lang="en-US" sz="4700" b="1" i="1" dirty="0">
+                <a:solidFill>
+                  <a:srgbClr val="FFFFFF"/>
+                </a:solidFill>
+                <a:latin typeface="Arial" pitchFamily="34" charset="0"/>
+                <a:ea typeface="Arial" pitchFamily="34" charset="-122"/>
+                <a:cs typeface="Arial" pitchFamily="34" charset="-120"/>
+              </a:rPr>
+              <a:t>Я радію, бо Спаситель -</a:t>
+            </a:r>
+            <a:endParaRPr lang="en-US" sz="4700" dirty="0"/>
+          </a:p>
+          <a:p>
+            <a:pPr algn="ctr" indent="0" marL="0">
+              <a:buNone/>
+            </a:pPr>
+            <a:r>
+              <a:rPr lang="en-US" sz="4700" b="1" i="1" dirty="0">
+                <a:solidFill>
+                  <a:srgbClr val="FFFFFF"/>
+                </a:solidFill>
+                <a:latin typeface="Arial" pitchFamily="34" charset="0"/>
+                <a:ea typeface="Arial" pitchFamily="34" charset="-122"/>
+                <a:cs typeface="Arial" pitchFamily="34" charset="-120"/>
+              </a:rPr>
+              <a:t>Джерело і Скарб душі моїй.</a:t>
+            </a:r>
+            <a:endParaRPr lang="en-US" sz="4700" dirty="0"/>
+          </a:p>
+          <a:p>
+            <a:pPr algn="ctr" indent="0" marL="0">
+              <a:buNone/>
+            </a:pPr>
+            <a:r>
+              <a:rPr lang="en-US" sz="4700" b="1" i="1" dirty="0">
+                <a:solidFill>
+                  <a:srgbClr val="FFFFFF"/>
+                </a:solidFill>
+                <a:latin typeface="Arial" pitchFamily="34" charset="0"/>
+                <a:ea typeface="Arial" pitchFamily="34" charset="-122"/>
+                <a:cs typeface="Arial" pitchFamily="34" charset="-120"/>
+              </a:rPr>
+              <a:t>Я Йому лиш довіряю –</a:t>
+            </a:r>
+            <a:endParaRPr lang="en-US" sz="4700" dirty="0"/>
+          </a:p>
+          <a:p>
+            <a:pPr algn="ctr" indent="0" marL="0">
+              <a:buNone/>
+            </a:pPr>
+            <a:r>
+              <a:rPr lang="en-US" sz="4700" b="1" i="1" dirty="0">
+                <a:solidFill>
+                  <a:srgbClr val="FFFFFF"/>
+                </a:solidFill>
+                <a:latin typeface="Arial" pitchFamily="34" charset="0"/>
+                <a:ea typeface="Arial" pitchFamily="34" charset="-122"/>
+                <a:cs typeface="Arial" pitchFamily="34" charset="-120"/>
+              </a:rPr>
+              <a:t>Спокій душа знайде </a:t>
+            </a:r>
+            <a:endParaRPr lang="en-US" sz="4700" dirty="0"/>
+          </a:p>
+          <a:p>
+            <a:pPr algn="ctr" indent="0" marL="0">
+              <a:buNone/>
+            </a:pPr>
+            <a:r>
+              <a:rPr lang="en-US" sz="4700" b="1" i="1" dirty="0">
+                <a:solidFill>
+                  <a:srgbClr val="FFFFFF"/>
+                </a:solidFill>
+                <a:latin typeface="Arial" pitchFamily="34" charset="0"/>
+                <a:ea typeface="Arial" pitchFamily="34" charset="-122"/>
+                <a:cs typeface="Arial" pitchFamily="34" charset="-120"/>
+              </a:rPr>
+              <a:t>лише в Христі!</a:t>
+            </a:r>
+            <a:endParaRPr lang="en-US" sz="4700" dirty="0"/>
+          </a:p>
+        </p:txBody>
+      </p:sp>
+    </p:spTree>
+  </p:cSld>
+  <p:clrMapOvr>
+    <a:masterClrMapping/>
+  </p:clrMapOvr>
+</p:sld>
+</file>
+
+<file path=ppt/slides/slide11.xml><?xml version="1.0" encoding="utf-8"?>
+<p:sld xmlns:a="http://schemas.openxmlformats.org/drawingml/2006/main" xmlns:r="http://schemas.openxmlformats.org/officeDocument/2006/relationships" xmlns:p="http://schemas.openxmlformats.org/presentationml/2006/main">
+  <p:cSld name="Slide 11">
+    <p:bg>
+      <p:bgPr>
+        <a:solidFill>
+          <a:srgbClr val="000000"/>
+        </a:solidFill>
+      </p:bgPr>
+    </p:bg>
+    <p:spTree>
+      <p:nvGrpSpPr>
+        <p:cNvPr id="1" name=""/>
+        <p:cNvGrpSpPr/>
+        <p:nvPr/>
+      </p:nvGrpSpPr>
+      <p:grpSpPr>
+        <a:xfrm>
+          <a:off x="0" y="0"/>
+          <a:ext cx="0" cy="0"/>
+          <a:chOff x="0" y="0"/>
+          <a:chExt cx="0" cy="0"/>
+        </a:xfrm>
+      </p:grpSpPr>
+      <p:sp>
+        <p:nvSpPr>
+          <p:cNvPr id="2" name="Text 0"/>
+          <p:cNvSpPr txBox="1"/>
+          <p:nvPr/>
+        </p:nvSpPr>
+        <p:spPr>
+          <a:xfrm>
+            <a:off x="548640" y="457200"/>
+            <a:ext cx="11064240" cy="5943600"/>
+          </a:xfrm>
+          <a:prstGeom prst="rect">
+            <a:avLst/>
+          </a:prstGeom>
+          <a:noFill/>
+          <a:ln/>
+        </p:spPr>
+        <p:txBody>
+          <a:bodyPr wrap="square" lIns="0" tIns="0" rIns="0" bIns="0" rtlCol="0" anchor="ctr"/>
+          <a:lstStyle/>
+          <a:p>
+            <a:pPr algn="ctr" indent="0" marL="0">
+              <a:buNone/>
+            </a:pPr>
+            <a:r>
+              <a:rPr lang="en-US" sz="4700" b="1" dirty="0">
+                <a:solidFill>
+                  <a:srgbClr val="FFFFFF"/>
+                </a:solidFill>
+                <a:latin typeface="Arial" pitchFamily="34" charset="0"/>
+                <a:ea typeface="Arial" pitchFamily="34" charset="-122"/>
+                <a:cs typeface="Arial" pitchFamily="34" charset="-120"/>
+              </a:rPr>
+              <a:t>Спокій душа знайде </a:t>
+            </a:r>
+            <a:endParaRPr lang="en-US" sz="4700" dirty="0"/>
+          </a:p>
+          <a:p>
+            <a:pPr algn="ctr" indent="0" marL="0">
+              <a:buNone/>
+            </a:pPr>
+            <a:r>
+              <a:rPr lang="en-US" sz="4700" b="1" dirty="0">
+                <a:solidFill>
+                  <a:srgbClr val="FFFFFF"/>
+                </a:solidFill>
+                <a:latin typeface="Arial" pitchFamily="34" charset="0"/>
+                <a:ea typeface="Arial" pitchFamily="34" charset="-122"/>
+                <a:cs typeface="Arial" pitchFamily="34" charset="-120"/>
+              </a:rPr>
+              <a:t>лише в Христі!</a:t>
+            </a:r>
+            <a:endParaRPr lang="en-US" sz="4700" dirty="0"/>
+          </a:p>
+          <a:p>
+            <a:pPr algn="ctr" indent="0" marL="0">
+              <a:buNone/>
+            </a:pPr>
+            <a:endParaRPr lang="en-US" sz="4700" dirty="0"/>
+          </a:p>
+          <a:p>
+            <a:pPr algn="ctr" indent="0" marL="0">
+              <a:buNone/>
+            </a:pPr>
+            <a:r>
+              <a:rPr lang="en-US" sz="4700" b="1" dirty="0">
+                <a:solidFill>
+                  <a:srgbClr val="FFFFFF"/>
+                </a:solidFill>
+                <a:latin typeface="Arial" pitchFamily="34" charset="0"/>
+                <a:ea typeface="Arial" pitchFamily="34" charset="-122"/>
+                <a:cs typeface="Arial" pitchFamily="34" charset="-120"/>
+              </a:rPr>
+              <a:t>***</a:t>
+            </a:r>
+            <a:endParaRPr lang="en-US" sz="4700" dirty="0"/>
           </a:p>
         </p:txBody>
       </p:sp>
@@ -1594,7 +2128,7 @@
               <a:buNone/>
             </a:pPr>
             <a:r>
-              <a:rPr lang="en-US" sz="4800" b="1" dirty="0">
+              <a:rPr lang="en-US" sz="4700" b="1" dirty="0">
                 <a:solidFill>
                   <a:srgbClr val="FFFFFF"/>
                 </a:solidFill>
@@ -1604,14 +2138,14 @@
               </a:rPr>
               <a:t>Чим справді цінний Богу я?</a:t>
             </a:r>
-            <a:endParaRPr lang="en-US" sz="4800" dirty="0"/>
-          </a:p>
-          <a:p>
-            <a:pPr algn="ctr" indent="0" marL="0">
-              <a:buNone/>
-            </a:pPr>
-            <a:r>
-              <a:rPr lang="en-US" sz="4800" b="1" dirty="0">
+            <a:endParaRPr lang="en-US" sz="4700" dirty="0"/>
+          </a:p>
+          <a:p>
+            <a:pPr algn="ctr" indent="0" marL="0">
+              <a:buNone/>
+            </a:pPr>
+            <a:r>
+              <a:rPr lang="en-US" sz="4700" b="1" dirty="0">
                 <a:solidFill>
                   <a:srgbClr val="FFFFFF"/>
                 </a:solidFill>
@@ -1621,58 +2155,41 @@
               </a:rPr>
               <a:t>Ніщо – багатство чи краса.</a:t>
             </a:r>
-            <a:endParaRPr lang="en-US" sz="4800" dirty="0"/>
-          </a:p>
-          <a:p>
-            <a:pPr algn="ctr" indent="0" marL="0">
-              <a:buNone/>
-            </a:pPr>
-            <a:r>
-              <a:rPr lang="en-US" sz="4800" b="1" dirty="0">
-                <a:solidFill>
-                  <a:srgbClr val="FFFFFF"/>
-                </a:solidFill>
-                <a:latin typeface="Arial" pitchFamily="34" charset="0"/>
-                <a:ea typeface="Arial" pitchFamily="34" charset="-122"/>
-                <a:cs typeface="Arial" pitchFamily="34" charset="-120"/>
-              </a:rPr>
-              <a:t>Христос пролив любов святу на хресті!</a:t>
-            </a:r>
-            <a:endParaRPr lang="en-US" sz="4800" dirty="0"/>
-          </a:p>
-          <a:p>
-            <a:pPr algn="ctr" indent="0" marL="0">
-              <a:buNone/>
-            </a:pPr>
-            <a:r>
-              <a:rPr lang="en-US" sz="4800" b="1" dirty="0">
-                <a:solidFill>
-                  <a:srgbClr val="FFFFFF"/>
-                </a:solidFill>
-                <a:latin typeface="Arial" pitchFamily="34" charset="0"/>
-                <a:ea typeface="Arial" pitchFamily="34" charset="-122"/>
-                <a:cs typeface="Arial" pitchFamily="34" charset="-120"/>
-              </a:rPr>
-              <a:t>Не маю слави у собі, y перемозі чи в біді</a:t>
-            </a:r>
-            <a:endParaRPr lang="en-US" sz="4800" dirty="0"/>
-          </a:p>
-          <a:p>
-            <a:pPr algn="ctr" indent="0" marL="0">
-              <a:buNone/>
-            </a:pPr>
-            <a:r>
-              <a:rPr lang="en-US" sz="4800" b="1" dirty="0">
-                <a:solidFill>
-                  <a:srgbClr val="FFFFFF"/>
-                </a:solidFill>
-                <a:latin typeface="Arial" pitchFamily="34" charset="0"/>
-                <a:ea typeface="Arial" pitchFamily="34" charset="-122"/>
-                <a:cs typeface="Arial" pitchFamily="34" charset="-120"/>
-              </a:rPr>
-              <a:t>Ісус за мене заплатив на хресті!</a:t>
-            </a:r>
-            <a:endParaRPr lang="en-US" sz="4800" dirty="0"/>
+            <a:endParaRPr lang="en-US" sz="4700" dirty="0"/>
+          </a:p>
+          <a:p>
+            <a:pPr algn="ctr" indent="0" marL="0">
+              <a:buNone/>
+            </a:pPr>
+            <a:r>
+              <a:rPr lang="en-US" sz="4700" b="1" dirty="0">
+                <a:solidFill>
+                  <a:srgbClr val="FFFFFF"/>
+                </a:solidFill>
+                <a:latin typeface="Arial" pitchFamily="34" charset="0"/>
+                <a:ea typeface="Arial" pitchFamily="34" charset="-122"/>
+                <a:cs typeface="Arial" pitchFamily="34" charset="-120"/>
+              </a:rPr>
+              <a:t>Христос пролив любов святу</a:t>
+            </a:r>
+            <a:endParaRPr lang="en-US" sz="4700" dirty="0"/>
+          </a:p>
+          <a:p>
+            <a:pPr algn="ctr" indent="0" marL="0">
+              <a:buNone/>
+            </a:pPr>
+            <a:r>
+              <a:rPr lang="en-US" sz="4700" b="1" dirty="0">
+                <a:solidFill>
+                  <a:srgbClr val="FFFFFF"/>
+                </a:solidFill>
+                <a:latin typeface="Arial" pitchFamily="34" charset="0"/>
+                <a:ea typeface="Arial" pitchFamily="34" charset="-122"/>
+                <a:cs typeface="Arial" pitchFamily="34" charset="-120"/>
+              </a:rPr>
+              <a:t>... на хресті!</a:t>
+            </a:r>
+            <a:endParaRPr lang="en-US" sz="4700" dirty="0"/>
           </a:p>
         </p:txBody>
       </p:sp>
@@ -1733,68 +2250,68 @@
               <a:buNone/>
             </a:pPr>
             <a:r>
-              <a:rPr lang="en-US" sz="4800" b="1" i="1" dirty="0">
-                <a:solidFill>
-                  <a:srgbClr val="FFFFFF"/>
-                </a:solidFill>
-                <a:latin typeface="Arial" pitchFamily="34" charset="0"/>
-                <a:ea typeface="Arial" pitchFamily="34" charset="-122"/>
-                <a:cs typeface="Arial" pitchFamily="34" charset="-120"/>
-              </a:rPr>
-              <a:t>Я радію, бо Спаситель -</a:t>
-            </a:r>
-            <a:endParaRPr lang="en-US" sz="4800" dirty="0"/>
-          </a:p>
-          <a:p>
-            <a:pPr algn="ctr" indent="0" marL="0">
-              <a:buNone/>
-            </a:pPr>
-            <a:r>
-              <a:rPr lang="en-US" sz="4800" b="1" i="1" dirty="0">
-                <a:solidFill>
-                  <a:srgbClr val="FFFFFF"/>
-                </a:solidFill>
-                <a:latin typeface="Arial" pitchFamily="34" charset="0"/>
-                <a:ea typeface="Arial" pitchFamily="34" charset="-122"/>
-                <a:cs typeface="Arial" pitchFamily="34" charset="-120"/>
-              </a:rPr>
-              <a:t>Джерело і Скарб душі моїй.</a:t>
-            </a:r>
-            <a:endParaRPr lang="en-US" sz="4800" dirty="0"/>
-          </a:p>
-          <a:p>
-            <a:pPr algn="ctr" indent="0" marL="0">
-              <a:buNone/>
-            </a:pPr>
-            <a:r>
-              <a:rPr lang="en-US" sz="4800" b="1" i="1" dirty="0">
-                <a:solidFill>
-                  <a:srgbClr val="FFFFFF"/>
-                </a:solidFill>
-                <a:latin typeface="Arial" pitchFamily="34" charset="0"/>
-                <a:ea typeface="Arial" pitchFamily="34" charset="-122"/>
-                <a:cs typeface="Arial" pitchFamily="34" charset="-120"/>
-              </a:rPr>
-              <a:t>Я Йому лиш довіряю –</a:t>
-            </a:r>
-            <a:endParaRPr lang="en-US" sz="4800" dirty="0"/>
-          </a:p>
-          <a:p>
-            <a:pPr algn="ctr" indent="0" marL="0">
-              <a:buNone/>
-            </a:pPr>
-            <a:r>
-              <a:rPr lang="en-US" sz="4800" b="1" i="1" dirty="0">
-                <a:solidFill>
-                  <a:srgbClr val="FFFFFF"/>
-                </a:solidFill>
-                <a:latin typeface="Arial" pitchFamily="34" charset="0"/>
-                <a:ea typeface="Arial" pitchFamily="34" charset="-122"/>
-                <a:cs typeface="Arial" pitchFamily="34" charset="-120"/>
-              </a:rPr>
-              <a:t>Спокій душа знайде лише в Христі!</a:t>
-            </a:r>
-            <a:endParaRPr lang="en-US" sz="4800" dirty="0"/>
+              <a:rPr lang="en-US" sz="4700" b="1" dirty="0">
+                <a:solidFill>
+                  <a:srgbClr val="FFFFFF"/>
+                </a:solidFill>
+                <a:latin typeface="Arial" pitchFamily="34" charset="0"/>
+                <a:ea typeface="Arial" pitchFamily="34" charset="-122"/>
+                <a:cs typeface="Arial" pitchFamily="34" charset="-120"/>
+              </a:rPr>
+              <a:t>Не маю слави у собі, </a:t>
+            </a:r>
+            <a:endParaRPr lang="en-US" sz="4700" dirty="0"/>
+          </a:p>
+          <a:p>
+            <a:pPr algn="ctr" indent="0" marL="0">
+              <a:buNone/>
+            </a:pPr>
+            <a:r>
+              <a:rPr lang="en-US" sz="4700" b="1" dirty="0">
+                <a:solidFill>
+                  <a:srgbClr val="FFFFFF"/>
+                </a:solidFill>
+                <a:latin typeface="Arial" pitchFamily="34" charset="0"/>
+                <a:ea typeface="Arial" pitchFamily="34" charset="-122"/>
+                <a:cs typeface="Arial" pitchFamily="34" charset="-120"/>
+              </a:rPr>
+              <a:t>y перемозі чи в біді</a:t>
+            </a:r>
+            <a:endParaRPr lang="en-US" sz="4700" dirty="0"/>
+          </a:p>
+          <a:p>
+            <a:pPr algn="ctr" indent="0" marL="0">
+              <a:buNone/>
+            </a:pPr>
+            <a:r>
+              <a:rPr lang="en-US" sz="4700" b="1" dirty="0">
+                <a:solidFill>
+                  <a:srgbClr val="FFFFFF"/>
+                </a:solidFill>
+                <a:latin typeface="Arial" pitchFamily="34" charset="0"/>
+                <a:ea typeface="Arial" pitchFamily="34" charset="-122"/>
+                <a:cs typeface="Arial" pitchFamily="34" charset="-120"/>
+              </a:rPr>
+              <a:t>Ісус за мене заплатив </a:t>
+            </a:r>
+            <a:endParaRPr lang="en-US" sz="4700" dirty="0"/>
+          </a:p>
+          <a:p>
+            <a:pPr algn="ctr" indent="0" marL="0">
+              <a:buNone/>
+            </a:pPr>
+            <a:r>
+              <a:rPr lang="en-US" sz="4700" b="1" dirty="0">
+                <a:solidFill>
+                  <a:srgbClr val="FFFFFF"/>
+                </a:solidFill>
+                <a:latin typeface="Arial" pitchFamily="34" charset="0"/>
+                <a:ea typeface="Arial" pitchFamily="34" charset="-122"/>
+                <a:cs typeface="Arial" pitchFamily="34" charset="-120"/>
+              </a:rPr>
+              <a:t>... на хресті!</a:t>
+            </a:r>
+            <a:endParaRPr lang="en-US" sz="4700" dirty="0"/>
           </a:p>
         </p:txBody>
       </p:sp>
@@ -1855,85 +2372,85 @@
               <a:buNone/>
             </a:pPr>
             <a:r>
-              <a:rPr lang="en-US" sz="4800" b="1" dirty="0">
-                <a:solidFill>
-                  <a:srgbClr val="FFFFFF"/>
-                </a:solidFill>
-                <a:latin typeface="Arial" pitchFamily="34" charset="0"/>
-                <a:ea typeface="Arial" pitchFamily="34" charset="-122"/>
-                <a:cs typeface="Arial" pitchFamily="34" charset="-120"/>
-              </a:rPr>
-              <a:t>Ми в’янемо, немов трава, минають юність і краса.</a:t>
-            </a:r>
-            <a:endParaRPr lang="en-US" sz="4800" dirty="0"/>
-          </a:p>
-          <a:p>
-            <a:pPr algn="ctr" indent="0" marL="0">
-              <a:buNone/>
-            </a:pPr>
-            <a:r>
-              <a:rPr lang="en-US" sz="4800" b="1" dirty="0">
-                <a:solidFill>
-                  <a:srgbClr val="FFFFFF"/>
-                </a:solidFill>
-                <a:latin typeface="Arial" pitchFamily="34" charset="0"/>
-                <a:ea typeface="Arial" pitchFamily="34" charset="-122"/>
-                <a:cs typeface="Arial" pitchFamily="34" charset="-120"/>
-              </a:rPr>
-              <a:t>Бог каже вічності слова Із хреста</a:t>
-            </a:r>
-            <a:endParaRPr lang="en-US" sz="4800" dirty="0"/>
-          </a:p>
-          <a:p>
-            <a:pPr algn="ctr" indent="0" marL="0">
-              <a:buNone/>
-            </a:pPr>
-            <a:r>
-              <a:rPr lang="en-US" sz="4800" b="1" dirty="0">
-                <a:solidFill>
-                  <a:srgbClr val="FFFFFF"/>
-                </a:solidFill>
-                <a:latin typeface="Arial" pitchFamily="34" charset="0"/>
-                <a:ea typeface="Arial" pitchFamily="34" charset="-122"/>
-                <a:cs typeface="Arial" pitchFamily="34" charset="-120"/>
-              </a:rPr>
-              <a:t>Багатство й влада проминуть –</a:t>
-            </a:r>
-            <a:endParaRPr lang="en-US" sz="4800" dirty="0"/>
-          </a:p>
-          <a:p>
-            <a:pPr algn="ctr" indent="0" marL="0">
-              <a:buNone/>
-            </a:pPr>
-            <a:r>
-              <a:rPr lang="en-US" sz="4800" b="1" dirty="0">
-                <a:solidFill>
-                  <a:srgbClr val="FFFFFF"/>
-                </a:solidFill>
-                <a:latin typeface="Arial" pitchFamily="34" charset="0"/>
-                <a:ea typeface="Arial" pitchFamily="34" charset="-122"/>
-                <a:cs typeface="Arial" pitchFamily="34" charset="-120"/>
-              </a:rPr>
-              <a:t>У них шукає людство суть.</a:t>
-            </a:r>
-            <a:endParaRPr lang="en-US" sz="4800" dirty="0"/>
-          </a:p>
-          <a:p>
-            <a:pPr algn="ctr" indent="0" marL="0">
-              <a:buNone/>
-            </a:pPr>
-            <a:r>
-              <a:rPr lang="en-US" sz="4800" b="1" dirty="0">
-                <a:solidFill>
-                  <a:srgbClr val="FFFFFF"/>
-                </a:solidFill>
-                <a:latin typeface="Arial" pitchFamily="34" charset="0"/>
-                <a:ea typeface="Arial" pitchFamily="34" charset="-122"/>
-                <a:cs typeface="Arial" pitchFamily="34" charset="-120"/>
-              </a:rPr>
-              <a:t>Я хочу знати лиш Христа на хресті</a:t>
-            </a:r>
-            <a:endParaRPr lang="en-US" sz="4800" dirty="0"/>
+              <a:rPr lang="en-US" sz="4700" b="1" i="1" dirty="0">
+                <a:solidFill>
+                  <a:srgbClr val="FFFFFF"/>
+                </a:solidFill>
+                <a:latin typeface="Arial" pitchFamily="34" charset="0"/>
+                <a:ea typeface="Arial" pitchFamily="34" charset="-122"/>
+                <a:cs typeface="Arial" pitchFamily="34" charset="-120"/>
+              </a:rPr>
+              <a:t>Я радію, бо Спаситель -</a:t>
+            </a:r>
+            <a:endParaRPr lang="en-US" sz="4700" dirty="0"/>
+          </a:p>
+          <a:p>
+            <a:pPr algn="ctr" indent="0" marL="0">
+              <a:buNone/>
+            </a:pPr>
+            <a:r>
+              <a:rPr lang="en-US" sz="4700" b="1" i="1" dirty="0">
+                <a:solidFill>
+                  <a:srgbClr val="FFFFFF"/>
+                </a:solidFill>
+                <a:latin typeface="Arial" pitchFamily="34" charset="0"/>
+                <a:ea typeface="Arial" pitchFamily="34" charset="-122"/>
+                <a:cs typeface="Arial" pitchFamily="34" charset="-120"/>
+              </a:rPr>
+              <a:t>Джерело і Скарб душі моїй.</a:t>
+            </a:r>
+            <a:endParaRPr lang="en-US" sz="4700" dirty="0"/>
+          </a:p>
+          <a:p>
+            <a:pPr algn="ctr" indent="0" marL="0">
+              <a:buNone/>
+            </a:pPr>
+            <a:r>
+              <a:rPr lang="en-US" sz="4700" b="1" i="1" dirty="0">
+                <a:solidFill>
+                  <a:srgbClr val="FFFFFF"/>
+                </a:solidFill>
+                <a:latin typeface="Arial" pitchFamily="34" charset="0"/>
+                <a:ea typeface="Arial" pitchFamily="34" charset="-122"/>
+                <a:cs typeface="Arial" pitchFamily="34" charset="-120"/>
+              </a:rPr>
+              <a:t>Я Йому лиш довіряю –</a:t>
+            </a:r>
+            <a:endParaRPr lang="en-US" sz="4700" dirty="0"/>
+          </a:p>
+          <a:p>
+            <a:pPr algn="ctr" indent="0" marL="0">
+              <a:buNone/>
+            </a:pPr>
+            <a:r>
+              <a:rPr lang="en-US" sz="4700" b="1" i="1" dirty="0">
+                <a:solidFill>
+                  <a:srgbClr val="FFFFFF"/>
+                </a:solidFill>
+                <a:latin typeface="Arial" pitchFamily="34" charset="0"/>
+                <a:ea typeface="Arial" pitchFamily="34" charset="-122"/>
+                <a:cs typeface="Arial" pitchFamily="34" charset="-120"/>
+              </a:rPr>
+              <a:t>Спокій душа знайде </a:t>
+            </a:r>
+            <a:endParaRPr lang="en-US" sz="4700" dirty="0"/>
+          </a:p>
+          <a:p>
+            <a:pPr algn="ctr" indent="0" marL="0">
+              <a:buNone/>
+            </a:pPr>
+            <a:r>
+              <a:rPr lang="en-US" sz="4700" b="1" i="1" dirty="0">
+                <a:solidFill>
+                  <a:srgbClr val="FFFFFF"/>
+                </a:solidFill>
+                <a:latin typeface="Arial" pitchFamily="34" charset="0"/>
+                <a:ea typeface="Arial" pitchFamily="34" charset="-122"/>
+                <a:cs typeface="Arial" pitchFamily="34" charset="-120"/>
+              </a:rPr>
+              <a:t>лише в Христі!</a:t>
+            </a:r>
+            <a:endParaRPr lang="en-US" sz="4700" dirty="0"/>
           </a:p>
         </p:txBody>
       </p:sp>
@@ -1994,68 +2511,68 @@
               <a:buNone/>
             </a:pPr>
             <a:r>
-              <a:rPr lang="en-US" sz="4800" b="1" i="1" dirty="0">
-                <a:solidFill>
-                  <a:srgbClr val="FFFFFF"/>
-                </a:solidFill>
-                <a:latin typeface="Arial" pitchFamily="34" charset="0"/>
-                <a:ea typeface="Arial" pitchFamily="34" charset="-122"/>
-                <a:cs typeface="Arial" pitchFamily="34" charset="-120"/>
-              </a:rPr>
-              <a:t>Я радію, бо Спаситель -</a:t>
-            </a:r>
-            <a:endParaRPr lang="en-US" sz="4800" dirty="0"/>
-          </a:p>
-          <a:p>
-            <a:pPr algn="ctr" indent="0" marL="0">
-              <a:buNone/>
-            </a:pPr>
-            <a:r>
-              <a:rPr lang="en-US" sz="4800" b="1" i="1" dirty="0">
-                <a:solidFill>
-                  <a:srgbClr val="FFFFFF"/>
-                </a:solidFill>
-                <a:latin typeface="Arial" pitchFamily="34" charset="0"/>
-                <a:ea typeface="Arial" pitchFamily="34" charset="-122"/>
-                <a:cs typeface="Arial" pitchFamily="34" charset="-120"/>
-              </a:rPr>
-              <a:t>Джерело і Скарб душі моїй.</a:t>
-            </a:r>
-            <a:endParaRPr lang="en-US" sz="4800" dirty="0"/>
-          </a:p>
-          <a:p>
-            <a:pPr algn="ctr" indent="0" marL="0">
-              <a:buNone/>
-            </a:pPr>
-            <a:r>
-              <a:rPr lang="en-US" sz="4800" b="1" i="1" dirty="0">
-                <a:solidFill>
-                  <a:srgbClr val="FFFFFF"/>
-                </a:solidFill>
-                <a:latin typeface="Arial" pitchFamily="34" charset="0"/>
-                <a:ea typeface="Arial" pitchFamily="34" charset="-122"/>
-                <a:cs typeface="Arial" pitchFamily="34" charset="-120"/>
-              </a:rPr>
-              <a:t>Я Йому лиш довіряю –</a:t>
-            </a:r>
-            <a:endParaRPr lang="en-US" sz="4800" dirty="0"/>
-          </a:p>
-          <a:p>
-            <a:pPr algn="ctr" indent="0" marL="0">
-              <a:buNone/>
-            </a:pPr>
-            <a:r>
-              <a:rPr lang="en-US" sz="4800" b="1" i="1" dirty="0">
-                <a:solidFill>
-                  <a:srgbClr val="FFFFFF"/>
-                </a:solidFill>
-                <a:latin typeface="Arial" pitchFamily="34" charset="0"/>
-                <a:ea typeface="Arial" pitchFamily="34" charset="-122"/>
-                <a:cs typeface="Arial" pitchFamily="34" charset="-120"/>
-              </a:rPr>
-              <a:t>Спокій душа знайде лише в Христі!</a:t>
-            </a:r>
-            <a:endParaRPr lang="en-US" sz="4800" dirty="0"/>
+              <a:rPr lang="en-US" sz="4700" b="1" dirty="0">
+                <a:solidFill>
+                  <a:srgbClr val="FFFFFF"/>
+                </a:solidFill>
+                <a:latin typeface="Arial" pitchFamily="34" charset="0"/>
+                <a:ea typeface="Arial" pitchFamily="34" charset="-122"/>
+                <a:cs typeface="Arial" pitchFamily="34" charset="-120"/>
+              </a:rPr>
+              <a:t>Ми в’янемо, немов трава, </a:t>
+            </a:r>
+            <a:endParaRPr lang="en-US" sz="4700" dirty="0"/>
+          </a:p>
+          <a:p>
+            <a:pPr algn="ctr" indent="0" marL="0">
+              <a:buNone/>
+            </a:pPr>
+            <a:r>
+              <a:rPr lang="en-US" sz="4700" b="1" dirty="0">
+                <a:solidFill>
+                  <a:srgbClr val="FFFFFF"/>
+                </a:solidFill>
+                <a:latin typeface="Arial" pitchFamily="34" charset="0"/>
+                <a:ea typeface="Arial" pitchFamily="34" charset="-122"/>
+                <a:cs typeface="Arial" pitchFamily="34" charset="-120"/>
+              </a:rPr>
+              <a:t>минають юність і краса.</a:t>
+            </a:r>
+            <a:endParaRPr lang="en-US" sz="4700" dirty="0"/>
+          </a:p>
+          <a:p>
+            <a:pPr algn="ctr" indent="0" marL="0">
+              <a:buNone/>
+            </a:pPr>
+            <a:r>
+              <a:rPr lang="en-US" sz="4700" b="1" dirty="0">
+                <a:solidFill>
+                  <a:srgbClr val="FFFFFF"/>
+                </a:solidFill>
+                <a:latin typeface="Arial" pitchFamily="34" charset="0"/>
+                <a:ea typeface="Arial" pitchFamily="34" charset="-122"/>
+                <a:cs typeface="Arial" pitchFamily="34" charset="-120"/>
+              </a:rPr>
+              <a:t>Бог каже вічності слова</a:t>
+            </a:r>
+            <a:endParaRPr lang="en-US" sz="4700" dirty="0"/>
+          </a:p>
+          <a:p>
+            <a:pPr algn="ctr" indent="0" marL="0">
+              <a:buNone/>
+            </a:pPr>
+            <a:r>
+              <a:rPr lang="en-US" sz="4700" b="1" dirty="0">
+                <a:solidFill>
+                  <a:srgbClr val="FFFFFF"/>
+                </a:solidFill>
+                <a:latin typeface="Arial" pitchFamily="34" charset="0"/>
+                <a:ea typeface="Arial" pitchFamily="34" charset="-122"/>
+                <a:cs typeface="Arial" pitchFamily="34" charset="-120"/>
+              </a:rPr>
+              <a:t>... Із хреста</a:t>
+            </a:r>
+            <a:endParaRPr lang="en-US" sz="4700" dirty="0"/>
           </a:p>
         </p:txBody>
       </p:sp>
@@ -2116,51 +2633,68 @@
               <a:buNone/>
             </a:pPr>
             <a:r>
-              <a:rPr lang="en-US" sz="4800" b="1" dirty="0">
-                <a:solidFill>
-                  <a:srgbClr val="FFFFFF"/>
-                </a:solidFill>
-                <a:latin typeface="Arial" pitchFamily="34" charset="0"/>
-                <a:ea typeface="Arial" pitchFamily="34" charset="-122"/>
-                <a:cs typeface="Arial" pitchFamily="34" charset="-120"/>
-              </a:rPr>
-              <a:t>Я хочу всім розповісти:</a:t>
-            </a:r>
-            <a:endParaRPr lang="en-US" sz="4800" dirty="0"/>
-          </a:p>
-          <a:p>
-            <a:pPr algn="ctr" indent="0" marL="0">
-              <a:buNone/>
-            </a:pPr>
-            <a:r>
-              <a:rPr lang="en-US" sz="4800" b="1" dirty="0">
-                <a:solidFill>
-                  <a:srgbClr val="FFFFFF"/>
-                </a:solidFill>
-                <a:latin typeface="Arial" pitchFamily="34" charset="0"/>
-                <a:ea typeface="Arial" pitchFamily="34" charset="-122"/>
-                <a:cs typeface="Arial" pitchFamily="34" charset="-120"/>
-              </a:rPr>
-              <a:t>Ісус прийшов мене спасти.</a:t>
-            </a:r>
-            <a:endParaRPr lang="en-US" sz="4800" dirty="0"/>
-          </a:p>
-          <a:p>
-            <a:pPr algn="ctr" indent="0" marL="0">
-              <a:buNone/>
-            </a:pPr>
-            <a:r>
-              <a:rPr lang="en-US" sz="4800" b="1" dirty="0">
-                <a:solidFill>
-                  <a:srgbClr val="FFFFFF"/>
-                </a:solidFill>
-                <a:latin typeface="Arial" pitchFamily="34" charset="0"/>
-                <a:ea typeface="Arial" pitchFamily="34" charset="-122"/>
-                <a:cs typeface="Arial" pitchFamily="34" charset="-120"/>
-              </a:rPr>
-              <a:t>Він цінність дав душі моїй на хресті</a:t>
-            </a:r>
-            <a:endParaRPr lang="en-US" sz="4800" dirty="0"/>
+              <a:rPr lang="en-US" sz="4700" b="1" dirty="0">
+                <a:solidFill>
+                  <a:srgbClr val="FFFFFF"/>
+                </a:solidFill>
+                <a:latin typeface="Arial" pitchFamily="34" charset="0"/>
+                <a:ea typeface="Arial" pitchFamily="34" charset="-122"/>
+                <a:cs typeface="Arial" pitchFamily="34" charset="-120"/>
+              </a:rPr>
+              <a:t>Багатство й влада проминуть –</a:t>
+            </a:r>
+            <a:endParaRPr lang="en-US" sz="4700" dirty="0"/>
+          </a:p>
+          <a:p>
+            <a:pPr algn="ctr" indent="0" marL="0">
+              <a:buNone/>
+            </a:pPr>
+            <a:r>
+              <a:rPr lang="en-US" sz="4700" b="1" dirty="0">
+                <a:solidFill>
+                  <a:srgbClr val="FFFFFF"/>
+                </a:solidFill>
+                <a:latin typeface="Arial" pitchFamily="34" charset="0"/>
+                <a:ea typeface="Arial" pitchFamily="34" charset="-122"/>
+                <a:cs typeface="Arial" pitchFamily="34" charset="-120"/>
+              </a:rPr>
+              <a:t>У них шукає людство суть.</a:t>
+            </a:r>
+            <a:endParaRPr lang="en-US" sz="4700" dirty="0"/>
+          </a:p>
+          <a:p>
+            <a:pPr algn="ctr" indent="0" marL="0">
+              <a:buNone/>
+            </a:pPr>
+            <a:r>
+              <a:rPr lang="en-US" sz="4700" b="1" dirty="0">
+                <a:solidFill>
+                  <a:srgbClr val="FFFFFF"/>
+                </a:solidFill>
+                <a:latin typeface="Arial" pitchFamily="34" charset="0"/>
+                <a:ea typeface="Arial" pitchFamily="34" charset="-122"/>
+                <a:cs typeface="Arial" pitchFamily="34" charset="-120"/>
+              </a:rPr>
+              <a:t>Я хочу знати лиш Христа</a:t>
+            </a:r>
+            <a:endParaRPr lang="en-US" sz="4700" dirty="0"/>
+          </a:p>
+          <a:p>
+            <a:pPr algn="ctr" indent="0" marL="0">
+              <a:buNone/>
+            </a:pPr>
+            <a:r>
+              <a:rPr lang="en-US" sz="4700" b="1" dirty="0">
+                <a:solidFill>
+                  <a:srgbClr val="FFFFFF"/>
+                </a:solidFill>
+                <a:latin typeface="Arial" pitchFamily="34" charset="0"/>
+                <a:ea typeface="Arial" pitchFamily="34" charset="-122"/>
+                <a:cs typeface="Arial" pitchFamily="34" charset="-120"/>
+              </a:rPr>
+              <a:t>... на хресті</a:t>
+            </a:r>
+            <a:endParaRPr lang="en-US" sz="4700" dirty="0"/>
           </a:p>
         </p:txBody>
       </p:sp>
@@ -2221,7 +2755,7 @@
               <a:buNone/>
             </a:pPr>
             <a:r>
-              <a:rPr lang="en-US" sz="4800" b="1" i="1" dirty="0">
+              <a:rPr lang="en-US" sz="4700" b="1" i="1" dirty="0">
                 <a:solidFill>
                   <a:srgbClr val="FFFFFF"/>
                 </a:solidFill>
@@ -2231,14 +2765,14 @@
               </a:rPr>
               <a:t>Я радію, бо Спаситель -</a:t>
             </a:r>
-            <a:endParaRPr lang="en-US" sz="4800" dirty="0"/>
-          </a:p>
-          <a:p>
-            <a:pPr algn="ctr" indent="0" marL="0">
-              <a:buNone/>
-            </a:pPr>
-            <a:r>
-              <a:rPr lang="en-US" sz="4800" b="1" i="1" dirty="0">
+            <a:endParaRPr lang="en-US" sz="4700" dirty="0"/>
+          </a:p>
+          <a:p>
+            <a:pPr algn="ctr" indent="0" marL="0">
+              <a:buNone/>
+            </a:pPr>
+            <a:r>
+              <a:rPr lang="en-US" sz="4700" b="1" i="1" dirty="0">
                 <a:solidFill>
                   <a:srgbClr val="FFFFFF"/>
                 </a:solidFill>
@@ -2248,14 +2782,14 @@
               </a:rPr>
               <a:t>Джерело і Скарб душі моїй.</a:t>
             </a:r>
-            <a:endParaRPr lang="en-US" sz="4800" dirty="0"/>
-          </a:p>
-          <a:p>
-            <a:pPr algn="ctr" indent="0" marL="0">
-              <a:buNone/>
-            </a:pPr>
-            <a:r>
-              <a:rPr lang="en-US" sz="4800" b="1" i="1" dirty="0">
+            <a:endParaRPr lang="en-US" sz="4700" dirty="0"/>
+          </a:p>
+          <a:p>
+            <a:pPr algn="ctr" indent="0" marL="0">
+              <a:buNone/>
+            </a:pPr>
+            <a:r>
+              <a:rPr lang="en-US" sz="4700" b="1" i="1" dirty="0">
                 <a:solidFill>
                   <a:srgbClr val="FFFFFF"/>
                 </a:solidFill>
@@ -2265,24 +2799,41 @@
               </a:rPr>
               <a:t>Я Йому лиш довіряю –</a:t>
             </a:r>
-            <a:endParaRPr lang="en-US" sz="4800" dirty="0"/>
-          </a:p>
-          <a:p>
-            <a:pPr algn="ctr" indent="0" marL="0">
-              <a:buNone/>
-            </a:pPr>
-            <a:r>
-              <a:rPr lang="en-US" sz="4800" b="1" i="1" dirty="0">
-                <a:solidFill>
-                  <a:srgbClr val="FFFFFF"/>
-                </a:solidFill>
-                <a:latin typeface="Arial" pitchFamily="34" charset="0"/>
-                <a:ea typeface="Arial" pitchFamily="34" charset="-122"/>
-                <a:cs typeface="Arial" pitchFamily="34" charset="-120"/>
-              </a:rPr>
-              <a:t>Спокій душа знайде лише в Христі!</a:t>
-            </a:r>
-            <a:endParaRPr lang="en-US" sz="4800" dirty="0"/>
+            <a:endParaRPr lang="en-US" sz="4700" dirty="0"/>
+          </a:p>
+          <a:p>
+            <a:pPr algn="ctr" indent="0" marL="0">
+              <a:buNone/>
+            </a:pPr>
+            <a:r>
+              <a:rPr lang="en-US" sz="4700" b="1" i="1" dirty="0">
+                <a:solidFill>
+                  <a:srgbClr val="FFFFFF"/>
+                </a:solidFill>
+                <a:latin typeface="Arial" pitchFamily="34" charset="0"/>
+                <a:ea typeface="Arial" pitchFamily="34" charset="-122"/>
+                <a:cs typeface="Arial" pitchFamily="34" charset="-120"/>
+              </a:rPr>
+              <a:t>Спокій душа знайде </a:t>
+            </a:r>
+            <a:endParaRPr lang="en-US" sz="4700" dirty="0"/>
+          </a:p>
+          <a:p>
+            <a:pPr algn="ctr" indent="0" marL="0">
+              <a:buNone/>
+            </a:pPr>
+            <a:r>
+              <a:rPr lang="en-US" sz="4700" b="1" i="1" dirty="0">
+                <a:solidFill>
+                  <a:srgbClr val="FFFFFF"/>
+                </a:solidFill>
+                <a:latin typeface="Arial" pitchFamily="34" charset="0"/>
+                <a:ea typeface="Arial" pitchFamily="34" charset="-122"/>
+                <a:cs typeface="Arial" pitchFamily="34" charset="-120"/>
+              </a:rPr>
+              <a:t>лише в Христі!</a:t>
+            </a:r>
+            <a:endParaRPr lang="en-US" sz="4700" dirty="0"/>
           </a:p>
         </p:txBody>
       </p:sp>
@@ -2343,7 +2894,129 @@
               <a:buNone/>
             </a:pPr>
             <a:r>
-              <a:rPr lang="en-US" sz="4800" b="1" i="1" dirty="0">
+              <a:rPr lang="en-US" sz="4700" b="1" dirty="0">
+                <a:solidFill>
+                  <a:srgbClr val="FFFFFF"/>
+                </a:solidFill>
+                <a:latin typeface="Arial" pitchFamily="34" charset="0"/>
+                <a:ea typeface="Arial" pitchFamily="34" charset="-122"/>
+                <a:cs typeface="Arial" pitchFamily="34" charset="-120"/>
+              </a:rPr>
+              <a:t>Я хочу всім розповісти:</a:t>
+            </a:r>
+            <a:endParaRPr lang="en-US" sz="4700" dirty="0"/>
+          </a:p>
+          <a:p>
+            <a:pPr algn="ctr" indent="0" marL="0">
+              <a:buNone/>
+            </a:pPr>
+            <a:r>
+              <a:rPr lang="en-US" sz="4700" b="1" dirty="0">
+                <a:solidFill>
+                  <a:srgbClr val="FFFFFF"/>
+                </a:solidFill>
+                <a:latin typeface="Arial" pitchFamily="34" charset="0"/>
+                <a:ea typeface="Arial" pitchFamily="34" charset="-122"/>
+                <a:cs typeface="Arial" pitchFamily="34" charset="-120"/>
+              </a:rPr>
+              <a:t>Ісус прийшов мене спасти.</a:t>
+            </a:r>
+            <a:endParaRPr lang="en-US" sz="4700" dirty="0"/>
+          </a:p>
+          <a:p>
+            <a:pPr algn="ctr" indent="0" marL="0">
+              <a:buNone/>
+            </a:pPr>
+            <a:r>
+              <a:rPr lang="en-US" sz="4700" b="1" dirty="0">
+                <a:solidFill>
+                  <a:srgbClr val="FFFFFF"/>
+                </a:solidFill>
+                <a:latin typeface="Arial" pitchFamily="34" charset="0"/>
+                <a:ea typeface="Arial" pitchFamily="34" charset="-122"/>
+                <a:cs typeface="Arial" pitchFamily="34" charset="-120"/>
+              </a:rPr>
+              <a:t>Він цінність дав душі моїй</a:t>
+            </a:r>
+            <a:endParaRPr lang="en-US" sz="4700" dirty="0"/>
+          </a:p>
+          <a:p>
+            <a:pPr algn="ctr" indent="0" marL="0">
+              <a:buNone/>
+            </a:pPr>
+            <a:r>
+              <a:rPr lang="en-US" sz="4700" b="1" dirty="0">
+                <a:solidFill>
+                  <a:srgbClr val="FFFFFF"/>
+                </a:solidFill>
+                <a:latin typeface="Arial" pitchFamily="34" charset="0"/>
+                <a:ea typeface="Arial" pitchFamily="34" charset="-122"/>
+                <a:cs typeface="Arial" pitchFamily="34" charset="-120"/>
+              </a:rPr>
+              <a:t>... на хресті</a:t>
+            </a:r>
+            <a:endParaRPr lang="en-US" sz="4700" dirty="0"/>
+          </a:p>
+        </p:txBody>
+      </p:sp>
+    </p:spTree>
+  </p:cSld>
+  <p:clrMapOvr>
+    <a:masterClrMapping/>
+  </p:clrMapOvr>
+</p:sld>
+</file>
+
+<file path=ppt/slides/slide9.xml><?xml version="1.0" encoding="utf-8"?>
+<p:sld xmlns:a="http://schemas.openxmlformats.org/drawingml/2006/main" xmlns:r="http://schemas.openxmlformats.org/officeDocument/2006/relationships" xmlns:p="http://schemas.openxmlformats.org/presentationml/2006/main">
+  <p:cSld name="Slide 9">
+    <p:bg>
+      <p:bgPr>
+        <a:solidFill>
+          <a:srgbClr val="000000"/>
+        </a:solidFill>
+      </p:bgPr>
+    </p:bg>
+    <p:spTree>
+      <p:nvGrpSpPr>
+        <p:cNvPr id="1" name=""/>
+        <p:cNvGrpSpPr/>
+        <p:nvPr/>
+      </p:nvGrpSpPr>
+      <p:grpSpPr>
+        <a:xfrm>
+          <a:off x="0" y="0"/>
+          <a:ext cx="0" cy="0"/>
+          <a:chOff x="0" y="0"/>
+          <a:chExt cx="0" cy="0"/>
+        </a:xfrm>
+      </p:grpSpPr>
+      <p:sp>
+        <p:nvSpPr>
+          <p:cNvPr id="2" name="Text 0"/>
+          <p:cNvSpPr txBox="1"/>
+          <p:nvPr/>
+        </p:nvSpPr>
+        <p:spPr>
+          <a:xfrm>
+            <a:off x="548640" y="457200"/>
+            <a:ext cx="11064240" cy="5943600"/>
+          </a:xfrm>
+          <a:prstGeom prst="rect">
+            <a:avLst/>
+          </a:prstGeom>
+          <a:noFill/>
+          <a:ln/>
+        </p:spPr>
+        <p:txBody>
+          <a:bodyPr wrap="square" lIns="0" tIns="0" rIns="0" bIns="0" rtlCol="0" anchor="ctr"/>
+          <a:lstStyle/>
+          <a:p>
+            <a:pPr algn="ctr" indent="0" marL="0">
+              <a:buNone/>
+            </a:pPr>
+            <a:r>
+              <a:rPr lang="en-US" sz="4700" b="1" i="1" dirty="0">
                 <a:solidFill>
                   <a:srgbClr val="FFFFFF"/>
                 </a:solidFill>
@@ -2353,14 +3026,14 @@
               </a:rPr>
               <a:t>Я радію, бо Спаситель -</a:t>
             </a:r>
-            <a:endParaRPr lang="en-US" sz="4800" dirty="0"/>
-          </a:p>
-          <a:p>
-            <a:pPr algn="ctr" indent="0" marL="0">
-              <a:buNone/>
-            </a:pPr>
-            <a:r>
-              <a:rPr lang="en-US" sz="4800" b="1" i="1" dirty="0">
+            <a:endParaRPr lang="en-US" sz="4700" dirty="0"/>
+          </a:p>
+          <a:p>
+            <a:pPr algn="ctr" indent="0" marL="0">
+              <a:buNone/>
+            </a:pPr>
+            <a:r>
+              <a:rPr lang="en-US" sz="4700" b="1" i="1" dirty="0">
                 <a:solidFill>
                   <a:srgbClr val="FFFFFF"/>
                 </a:solidFill>
@@ -2370,14 +3043,14 @@
               </a:rPr>
               <a:t>Джерело і Скарб душі моїй.</a:t>
             </a:r>
-            <a:endParaRPr lang="en-US" sz="4800" dirty="0"/>
-          </a:p>
-          <a:p>
-            <a:pPr algn="ctr" indent="0" marL="0">
-              <a:buNone/>
-            </a:pPr>
-            <a:r>
-              <a:rPr lang="en-US" sz="4800" b="1" i="1" dirty="0">
+            <a:endParaRPr lang="en-US" sz="4700" dirty="0"/>
+          </a:p>
+          <a:p>
+            <a:pPr algn="ctr" indent="0" marL="0">
+              <a:buNone/>
+            </a:pPr>
+            <a:r>
+              <a:rPr lang="en-US" sz="4700" b="1" i="1" dirty="0">
                 <a:solidFill>
                   <a:srgbClr val="FFFFFF"/>
                 </a:solidFill>
@@ -2387,58 +3060,41 @@
               </a:rPr>
               <a:t>Я Йому лиш довіряю –</a:t>
             </a:r>
-            <a:endParaRPr lang="en-US" sz="4800" dirty="0"/>
-          </a:p>
-          <a:p>
-            <a:pPr algn="ctr" indent="0" marL="0">
-              <a:buNone/>
-            </a:pPr>
-            <a:r>
-              <a:rPr lang="en-US" sz="4800" b="1" i="1" dirty="0">
-                <a:solidFill>
-                  <a:srgbClr val="FFFFFF"/>
-                </a:solidFill>
-                <a:latin typeface="Arial" pitchFamily="34" charset="0"/>
-                <a:ea typeface="Arial" pitchFamily="34" charset="-122"/>
-                <a:cs typeface="Arial" pitchFamily="34" charset="-120"/>
-              </a:rPr>
-              <a:t>Спокій душа знайде лише в Христі!</a:t>
-            </a:r>
-            <a:endParaRPr lang="en-US" sz="4800" dirty="0"/>
-          </a:p>
-          <a:p>
-            <a:pPr algn="ctr" indent="0" marL="0">
-              <a:buNone/>
-            </a:pPr>
-            <a:r>
-              <a:rPr lang="en-US" sz="4800" b="1" i="1" dirty="0">
-                <a:solidFill>
-                  <a:srgbClr val="FFFFFF"/>
-                </a:solidFill>
-                <a:latin typeface="Arial" pitchFamily="34" charset="0"/>
-                <a:ea typeface="Arial" pitchFamily="34" charset="-122"/>
-                <a:cs typeface="Arial" pitchFamily="34" charset="-120"/>
-              </a:rPr>
-              <a:t>Спокій душа знайде лише в Христі!</a:t>
-            </a:r>
-            <a:endParaRPr lang="en-US" sz="4800" dirty="0"/>
-          </a:p>
-          <a:p>
-            <a:pPr algn="ctr" indent="0" marL="0">
-              <a:buNone/>
-            </a:pPr>
-            <a:r>
-              <a:rPr lang="en-US" sz="4800" b="1" i="1" dirty="0">
-                <a:solidFill>
-                  <a:srgbClr val="FFFFFF"/>
-                </a:solidFill>
-                <a:latin typeface="Arial" pitchFamily="34" charset="0"/>
-                <a:ea typeface="Arial" pitchFamily="34" charset="-122"/>
-                <a:cs typeface="Arial" pitchFamily="34" charset="-120"/>
-              </a:rPr>
-              <a:t>***</a:t>
-            </a:r>
-            <a:endParaRPr lang="en-US" sz="4800" dirty="0"/>
+            <a:endParaRPr lang="en-US" sz="4700" dirty="0"/>
+          </a:p>
+          <a:p>
+            <a:pPr algn="ctr" indent="0" marL="0">
+              <a:buNone/>
+            </a:pPr>
+            <a:r>
+              <a:rPr lang="en-US" sz="4700" b="1" i="1" dirty="0">
+                <a:solidFill>
+                  <a:srgbClr val="FFFFFF"/>
+                </a:solidFill>
+                <a:latin typeface="Arial" pitchFamily="34" charset="0"/>
+                <a:ea typeface="Arial" pitchFamily="34" charset="-122"/>
+                <a:cs typeface="Arial" pitchFamily="34" charset="-120"/>
+              </a:rPr>
+              <a:t>Спокій душа знайде </a:t>
+            </a:r>
+            <a:endParaRPr lang="en-US" sz="4700" dirty="0"/>
+          </a:p>
+          <a:p>
+            <a:pPr algn="ctr" indent="0" marL="0">
+              <a:buNone/>
+            </a:pPr>
+            <a:r>
+              <a:rPr lang="en-US" sz="4700" b="1" i="1" dirty="0">
+                <a:solidFill>
+                  <a:srgbClr val="FFFFFF"/>
+                </a:solidFill>
+                <a:latin typeface="Arial" pitchFamily="34" charset="0"/>
+                <a:ea typeface="Arial" pitchFamily="34" charset="-122"/>
+                <a:cs typeface="Arial" pitchFamily="34" charset="-120"/>
+              </a:rPr>
+              <a:t>лише в Христі!</a:t>
+            </a:r>
+            <a:endParaRPr lang="en-US" sz="4700" dirty="0"/>
           </a:p>
         </p:txBody>
       </p:sp>

</xml_diff>